<commit_message>
pc 2 laptop 4-28-26
</commit_message>
<xml_diff>
--- a/MA spring 2026/The effects of ALAN on fish behavior.pptx
+++ b/MA spring 2026/The effects of ALAN on fish behavior.pptx
@@ -5,10 +5,10 @@
     <p:sldMasterId id="2147483763" r:id="rId4"/>
   </p:sldMasterIdLst>
   <p:notesMasterIdLst>
-    <p:notesMasterId r:id="rId21"/>
+    <p:notesMasterId r:id="rId16"/>
   </p:notesMasterIdLst>
   <p:handoutMasterIdLst>
-    <p:handoutMasterId r:id="rId22"/>
+    <p:handoutMasterId r:id="rId17"/>
   </p:handoutMasterIdLst>
   <p:sldIdLst>
     <p:sldId id="1497" r:id="rId5"/>
@@ -22,11 +22,6 @@
     <p:sldId id="1502" r:id="rId13"/>
     <p:sldId id="1503" r:id="rId14"/>
     <p:sldId id="1506" r:id="rId15"/>
-    <p:sldId id="1508" r:id="rId16"/>
-    <p:sldId id="1517" r:id="rId17"/>
-    <p:sldId id="1509" r:id="rId18"/>
-    <p:sldId id="1511" r:id="rId19"/>
-    <p:sldId id="1512" r:id="rId20"/>
   </p:sldIdLst>
   <p:sldSz cx="12192000" cy="6858000"/>
   <p:notesSz cx="6858000" cy="9144000"/>
@@ -236,7 +231,7 @@
           <a:p>
             <a:fld id="{D5D1EC30-5B0B-48D0-A1A8-66A96720DF24}" type="datetimeFigureOut">
               <a:rPr lang="en-US" smtClean="0"/>
-              <a:t>4/27/2026</a:t>
+              <a:t>4/28/2026</a:t>
             </a:fld>
             <a:endParaRPr lang="en-US" dirty="0"/>
           </a:p>
@@ -413,7 +408,7 @@
           <a:p>
             <a:fld id="{69F68A4D-42A7-45F7-9930-00E8DCB48D7E}" type="datetimeFigureOut">
               <a:rPr lang="en-US" smtClean="0"/>
-              <a:t>4/27/2026</a:t>
+              <a:t>4/28/2026</a:t>
             </a:fld>
             <a:endParaRPr lang="en-US" dirty="0"/>
           </a:p>
@@ -680,6 +675,90 @@
 </p:notesMaster>
 </file>
 
+<file path=ppt/notesSlides/notesSlide1.xml><?xml version="1.0" encoding="utf-8"?>
+<p:notes xmlns:a="http://schemas.openxmlformats.org/drawingml/2006/main" xmlns:r="http://schemas.openxmlformats.org/officeDocument/2006/relationships" xmlns:p="http://schemas.openxmlformats.org/presentationml/2006/main">
+  <p:cSld>
+    <p:spTree>
+      <p:nvGrpSpPr>
+        <p:cNvPr id="1" name=""/>
+        <p:cNvGrpSpPr/>
+        <p:nvPr/>
+      </p:nvGrpSpPr>
+      <p:grpSpPr>
+        <a:xfrm>
+          <a:off x="0" y="0"/>
+          <a:ext cx="0" cy="0"/>
+          <a:chOff x="0" y="0"/>
+          <a:chExt cx="0" cy="0"/>
+        </a:xfrm>
+      </p:grpSpPr>
+      <p:sp>
+        <p:nvSpPr>
+          <p:cNvPr id="2" name="Slide Image Placeholder 1"/>
+          <p:cNvSpPr>
+            <a:spLocks noGrp="1" noRot="1" noChangeAspect="1"/>
+          </p:cNvSpPr>
+          <p:nvPr>
+            <p:ph type="sldImg"/>
+          </p:nvPr>
+        </p:nvSpPr>
+        <p:spPr/>
+      </p:sp>
+      <p:sp>
+        <p:nvSpPr>
+          <p:cNvPr id="3" name="Notes Placeholder 2"/>
+          <p:cNvSpPr>
+            <a:spLocks noGrp="1"/>
+          </p:cNvSpPr>
+          <p:nvPr>
+            <p:ph type="body" idx="1"/>
+          </p:nvPr>
+        </p:nvSpPr>
+        <p:spPr/>
+        <p:txBody>
+          <a:bodyPr/>
+          <a:lstStyle/>
+          <a:p>
+            <a:endParaRPr lang="en-US" dirty="0"/>
+          </a:p>
+        </p:txBody>
+      </p:sp>
+      <p:sp>
+        <p:nvSpPr>
+          <p:cNvPr id="4" name="Slide Number Placeholder 3"/>
+          <p:cNvSpPr>
+            <a:spLocks noGrp="1"/>
+          </p:cNvSpPr>
+          <p:nvPr>
+            <p:ph type="sldNum" sz="quarter" idx="5"/>
+          </p:nvPr>
+        </p:nvSpPr>
+        <p:spPr/>
+        <p:txBody>
+          <a:bodyPr/>
+          <a:lstStyle/>
+          <a:p>
+            <a:fld id="{BFDD6F49-EBB7-4CCF-97A8-E526BB28BB69}" type="slidenum">
+              <a:rPr lang="en-US" smtClean="0"/>
+              <a:t>8</a:t>
+            </a:fld>
+            <a:endParaRPr lang="en-US" dirty="0"/>
+          </a:p>
+        </p:txBody>
+      </p:sp>
+    </p:spTree>
+    <p:extLst>
+      <p:ext uri="{BB962C8B-B14F-4D97-AF65-F5344CB8AC3E}">
+        <p14:creationId xmlns:p14="http://schemas.microsoft.com/office/powerpoint/2010/main" val="1622124959"/>
+      </p:ext>
+    </p:extLst>
+  </p:cSld>
+  <p:clrMapOvr>
+    <a:masterClrMapping/>
+  </p:clrMapOvr>
+</p:notes>
+</file>
+
 <file path=ppt/slideLayouts/slideLayout1.xml><?xml version="1.0" encoding="utf-8"?>
 <p:sldLayout xmlns:a="http://schemas.openxmlformats.org/drawingml/2006/main" xmlns:r="http://schemas.openxmlformats.org/officeDocument/2006/relationships" xmlns:p="http://schemas.openxmlformats.org/presentationml/2006/main" preserve="1">
   <p:cSld name="Title with Picture">
@@ -886,7 +965,7 @@
           <a:p>
             <a:fld id="{B3EF4EF1-D9A3-1B4B-824F-63DEB13C7D30}" type="datetime1">
               <a:rPr lang="en-US" smtClean="0"/>
-              <a:t>4/27/2026</a:t>
+              <a:t>4/28/2026</a:t>
             </a:fld>
             <a:endParaRPr lang="en-US" dirty="0"/>
           </a:p>
@@ -1313,7 +1392,7 @@
             <a:fld id="{111D9101-0A20-A644-B98A-5AAB72007147}" type="datetime1">
               <a:rPr lang="en-US" smtClean="0"/>
               <a:pPr/>
-              <a:t>4/27/2026</a:t>
+              <a:t>4/28/2026</a:t>
             </a:fld>
             <a:endParaRPr lang="en-US" dirty="0"/>
           </a:p>
@@ -1593,7 +1672,7 @@
           <a:p>
             <a:fld id="{7C3D50EA-7C99-C642-BDB8-78B050F52948}" type="datetime1">
               <a:rPr lang="en-US" smtClean="0"/>
-              <a:t>4/27/2026</a:t>
+              <a:t>4/28/2026</a:t>
             </a:fld>
             <a:endParaRPr lang="en-US" dirty="0"/>
           </a:p>
@@ -2036,7 +2115,7 @@
           <a:p>
             <a:fld id="{F157801D-503B-EF46-ADEC-5C959CCCA979}" type="datetime1">
               <a:rPr lang="en-US" smtClean="0"/>
-              <a:t>4/27/2026</a:t>
+              <a:t>4/28/2026</a:t>
             </a:fld>
             <a:endParaRPr lang="en-US" dirty="0"/>
           </a:p>
@@ -2494,7 +2573,7 @@
           <a:p>
             <a:fld id="{0DEB9912-DA83-3943-A195-65BA8C060432}" type="datetime1">
               <a:rPr lang="en-US" smtClean="0"/>
-              <a:t>4/27/2026</a:t>
+              <a:t>4/28/2026</a:t>
             </a:fld>
             <a:endParaRPr lang="en-US" dirty="0"/>
           </a:p>
@@ -2955,7 +3034,7 @@
           <a:p>
             <a:fld id="{9B0D4203-094B-0D4B-879D-04F5C4F2A8FE}" type="datetime1">
               <a:rPr lang="en-US" smtClean="0"/>
-              <a:t>4/27/2026</a:t>
+              <a:t>4/28/2026</a:t>
             </a:fld>
             <a:endParaRPr lang="en-US" dirty="0"/>
           </a:p>
@@ -3174,7 +3253,7 @@
           <a:p>
             <a:fld id="{69E0DAB2-5272-0346-9ECD-E0A6C2764DB4}" type="datetime1">
               <a:rPr lang="en-US" smtClean="0"/>
-              <a:t>4/27/2026</a:t>
+              <a:t>4/28/2026</a:t>
             </a:fld>
             <a:endParaRPr lang="en-US" dirty="0"/>
           </a:p>
@@ -3393,7 +3472,7 @@
           <a:p>
             <a:fld id="{DC184B29-56AA-9C42-ADF3-4AB1EB6F403E}" type="datetime1">
               <a:rPr lang="en-US" smtClean="0"/>
-              <a:t>4/27/2026</a:t>
+              <a:t>4/28/2026</a:t>
             </a:fld>
             <a:endParaRPr lang="en-US" dirty="0"/>
           </a:p>
@@ -3612,7 +3691,7 @@
           <a:p>
             <a:fld id="{EEABA7D4-F682-584C-BBAE-B4231503FB62}" type="datetime1">
               <a:rPr lang="en-US" smtClean="0"/>
-              <a:t>4/27/2026</a:t>
+              <a:t>4/28/2026</a:t>
             </a:fld>
             <a:endParaRPr lang="en-US" dirty="0"/>
           </a:p>
@@ -3831,7 +3910,7 @@
           <a:p>
             <a:fld id="{2BBC5130-9426-2744-B098-3B51DCEC7F04}" type="datetime1">
               <a:rPr lang="en-US" smtClean="0"/>
-              <a:t>4/27/2026</a:t>
+              <a:t>4/28/2026</a:t>
             </a:fld>
             <a:endParaRPr lang="en-US" dirty="0"/>
           </a:p>
@@ -4213,7 +4292,7 @@
           <a:p>
             <a:fld id="{7CB74803-9A2C-034F-B1A1-F6470E6CA660}" type="datetime1">
               <a:rPr lang="en-US" smtClean="0"/>
-              <a:t>4/27/2026</a:t>
+              <a:t>4/28/2026</a:t>
             </a:fld>
             <a:endParaRPr lang="en-US" dirty="0"/>
           </a:p>
@@ -4426,7 +4505,7 @@
           <a:p>
             <a:fld id="{841A8624-D4B9-7C44-BA3F-B13CDFB276DF}" type="datetime1">
               <a:rPr lang="en-US" smtClean="0"/>
-              <a:t>4/27/2026</a:t>
+              <a:t>4/28/2026</a:t>
             </a:fld>
             <a:endParaRPr lang="en-US" dirty="0"/>
           </a:p>
@@ -4803,7 +4882,7 @@
           <a:p>
             <a:fld id="{71D3B9E8-F3C1-6446-B37C-65190666CE5C}" type="datetime1">
               <a:rPr lang="en-US" smtClean="0"/>
-              <a:t>4/27/2026</a:t>
+              <a:t>4/28/2026</a:t>
             </a:fld>
             <a:endParaRPr lang="en-US" dirty="0"/>
           </a:p>
@@ -5195,7 +5274,7 @@
           <a:p>
             <a:fld id="{C94DBE0E-BA63-894B-AD67-B5534C763ECE}" type="datetime1">
               <a:rPr lang="en-US" smtClean="0"/>
-              <a:t>4/27/2026</a:t>
+              <a:t>4/28/2026</a:t>
             </a:fld>
             <a:endParaRPr lang="en-US" dirty="0"/>
           </a:p>
@@ -5572,7 +5651,7 @@
           <a:p>
             <a:fld id="{998EB195-6C83-E04A-B652-F00DFBE24657}" type="datetime1">
               <a:rPr lang="en-US" smtClean="0"/>
-              <a:t>4/27/2026</a:t>
+              <a:t>4/28/2026</a:t>
             </a:fld>
             <a:endParaRPr lang="en-US" dirty="0"/>
           </a:p>
@@ -5983,7 +6062,7 @@
           <a:p>
             <a:fld id="{CF19ABAC-CEC0-3744-94EB-1D764E2366A2}" type="datetime1">
               <a:rPr lang="en-US" smtClean="0"/>
-              <a:t>4/27/2026</a:t>
+              <a:t>4/28/2026</a:t>
             </a:fld>
             <a:endParaRPr lang="en-US" dirty="0"/>
           </a:p>
@@ -6461,7 +6540,7 @@
           <a:p>
             <a:fld id="{E2AAE019-E83D-CB42-A578-B360638D96E4}" type="datetime1">
               <a:rPr lang="en-US" smtClean="0"/>
-              <a:t>4/27/2026</a:t>
+              <a:t>4/28/2026</a:t>
             </a:fld>
             <a:endParaRPr lang="en-US" dirty="0"/>
           </a:p>
@@ -6826,7 +6905,7 @@
           <a:p>
             <a:fld id="{4ED57CA4-9B91-014F-9006-ED823B296BC5}" type="datetime1">
               <a:rPr lang="en-US" smtClean="0"/>
-              <a:t>4/27/2026</a:t>
+              <a:t>4/28/2026</a:t>
             </a:fld>
             <a:endParaRPr lang="en-US" dirty="0"/>
           </a:p>
@@ -7239,7 +7318,7 @@
           <a:p>
             <a:fld id="{5B19DAFB-FAB1-764F-BE9B-0C575278000C}" type="datetime1">
               <a:rPr lang="en-US" smtClean="0"/>
-              <a:t>4/27/2026</a:t>
+              <a:t>4/28/2026</a:t>
             </a:fld>
             <a:endParaRPr lang="en-US" dirty="0"/>
           </a:p>
@@ -7683,7 +7762,7 @@
           <a:p>
             <a:fld id="{2FF7BC53-6B45-7742-9EBA-CB5E7E199EB6}" type="datetime1">
               <a:rPr lang="en-US" smtClean="0"/>
-              <a:t>4/27/2026</a:t>
+              <a:t>4/28/2026</a:t>
             </a:fld>
             <a:endParaRPr lang="en-US" dirty="0"/>
           </a:p>
@@ -8103,7 +8182,7 @@
           <a:p>
             <a:fld id="{A5B05B6C-DEDB-7544-9F53-A4801D50D3DC}" type="datetime1">
               <a:rPr lang="en-US" smtClean="0"/>
-              <a:t>4/27/2026</a:t>
+              <a:t>4/28/2026</a:t>
             </a:fld>
             <a:endParaRPr lang="en-US" dirty="0"/>
           </a:p>
@@ -8573,7 +8652,7 @@
           <a:p>
             <a:fld id="{F67BC866-C4B3-4A49-A8DC-A0BE5C9E8ADF}" type="datetime1">
               <a:rPr lang="en-US" smtClean="0"/>
-              <a:t>4/27/2026</a:t>
+              <a:t>4/28/2026</a:t>
             </a:fld>
             <a:endParaRPr lang="en-US" dirty="0"/>
           </a:p>
@@ -8995,7 +9074,7 @@
           <a:p>
             <a:fld id="{52DEFB05-7E9F-904D-9899-4BFD23D31172}" type="datetime1">
               <a:rPr lang="en-US" smtClean="0"/>
-              <a:t>4/27/2026</a:t>
+              <a:t>4/28/2026</a:t>
             </a:fld>
             <a:endParaRPr lang="en-US" dirty="0"/>
           </a:p>
@@ -9311,7 +9390,7 @@
           <a:p>
             <a:fld id="{E50B7C8D-329B-1A41-996A-C00FEEB4F1BF}" type="datetime1">
               <a:rPr lang="en-US" smtClean="0"/>
-              <a:t>4/27/2026</a:t>
+              <a:t>4/28/2026</a:t>
             </a:fld>
             <a:endParaRPr lang="en-US" dirty="0"/>
           </a:p>
@@ -9611,7 +9690,7 @@
           <a:p>
             <a:fld id="{13493ED9-EFBD-5A47-956E-678E362C5636}" type="datetime1">
               <a:rPr lang="en-US" smtClean="0"/>
-              <a:t>4/27/2026</a:t>
+              <a:t>4/28/2026</a:t>
             </a:fld>
             <a:endParaRPr lang="en-US" dirty="0"/>
           </a:p>
@@ -9772,7 +9851,7 @@
           <a:p>
             <a:fld id="{B10367D4-204C-404A-8464-46B87B775F25}" type="datetime1">
               <a:rPr lang="en-US" smtClean="0"/>
-              <a:t>4/27/2026</a:t>
+              <a:t>4/28/2026</a:t>
             </a:fld>
             <a:endParaRPr lang="en-US" dirty="0"/>
           </a:p>
@@ -10192,7 +10271,7 @@
           <a:p>
             <a:fld id="{4B53CD41-8253-8740-8961-F06C3711FE73}" type="datetime1">
               <a:rPr lang="en-US" smtClean="0"/>
-              <a:t>4/27/2026</a:t>
+              <a:t>4/28/2026</a:t>
             </a:fld>
             <a:endParaRPr lang="en-US" dirty="0"/>
           </a:p>
@@ -10464,7 +10543,7 @@
           <a:p>
             <a:fld id="{6D0C54A3-95B5-7540-93F4-9DA873291FAC}" type="datetime1">
               <a:rPr lang="en-US" smtClean="0"/>
-              <a:t>4/27/2026</a:t>
+              <a:t>4/28/2026</a:t>
             </a:fld>
             <a:endParaRPr lang="en-US" dirty="0"/>
           </a:p>
@@ -10736,7 +10815,7 @@
           <a:p>
             <a:fld id="{84EBD702-F775-114B-846E-EFE6911639ED}" type="datetime1">
               <a:rPr lang="en-US" smtClean="0"/>
-              <a:t>4/27/2026</a:t>
+              <a:t>4/28/2026</a:t>
             </a:fld>
             <a:endParaRPr lang="en-US" dirty="0"/>
           </a:p>
@@ -11118,7 +11197,7 @@
           <a:p>
             <a:fld id="{E2AAE019-E83D-CB42-A578-B360638D96E4}" type="datetime1">
               <a:rPr lang="en-US" smtClean="0"/>
-              <a:t>4/27/2026</a:t>
+              <a:t>4/28/2026</a:t>
             </a:fld>
             <a:endParaRPr lang="en-US" dirty="0"/>
           </a:p>
@@ -11539,7 +11618,7 @@
           <a:p>
             <a:fld id="{E2AAE019-E83D-CB42-A578-B360638D96E4}" type="datetime1">
               <a:rPr lang="en-US" smtClean="0"/>
-              <a:t>4/27/2026</a:t>
+              <a:t>4/28/2026</a:t>
             </a:fld>
             <a:endParaRPr lang="en-US" dirty="0"/>
           </a:p>
@@ -11784,7 +11863,7 @@
           <a:p>
             <a:fld id="{EA9CBBDB-DB6A-8043-A23A-E4D514668CA9}" type="datetime1">
               <a:rPr lang="en-US" smtClean="0"/>
-              <a:t>4/27/2026</a:t>
+              <a:t>4/28/2026</a:t>
             </a:fld>
             <a:endParaRPr lang="en-US" dirty="0"/>
           </a:p>
@@ -11997,7 +12076,7 @@
           <a:p>
             <a:fld id="{9CA8FF74-D6A8-484C-8E59-ED45708650B1}" type="datetime1">
               <a:rPr lang="en-US" smtClean="0"/>
-              <a:t>4/27/2026</a:t>
+              <a:t>4/28/2026</a:t>
             </a:fld>
             <a:endParaRPr lang="en-US" dirty="0"/>
           </a:p>
@@ -12405,7 +12484,7 @@
           <a:p>
             <a:fld id="{253768E5-88AD-F345-813B-E822455F98B0}" type="datetime1">
               <a:rPr lang="en-US" smtClean="0"/>
-              <a:t>4/27/2026</a:t>
+              <a:t>4/28/2026</a:t>
             </a:fld>
             <a:endParaRPr lang="en-US" dirty="0"/>
           </a:p>
@@ -12655,7 +12734,7 @@
           <a:p>
             <a:fld id="{85D88237-8CC6-BF45-96C4-CF90C4DB2128}" type="datetime1">
               <a:rPr lang="en-US" smtClean="0"/>
-              <a:t>4/27/2026</a:t>
+              <a:t>4/28/2026</a:t>
             </a:fld>
             <a:endParaRPr lang="en-US" dirty="0"/>
           </a:p>
@@ -12914,7 +12993,7 @@
           <a:p>
             <a:fld id="{160AFA9F-5F67-2743-BC9C-9DCD4B6649F8}" type="datetime1">
               <a:rPr lang="en-US" smtClean="0"/>
-              <a:t>4/27/2026</a:t>
+              <a:t>4/28/2026</a:t>
             </a:fld>
             <a:endParaRPr lang="en-US" dirty="0"/>
           </a:p>
@@ -13175,7 +13254,7 @@
           <a:p>
             <a:fld id="{AB7ADF8E-C5F8-B94D-B79F-BB5E05403220}" type="datetime1">
               <a:rPr lang="en-US" smtClean="0"/>
-              <a:t>4/27/2026</a:t>
+              <a:t>4/28/2026</a:t>
             </a:fld>
             <a:endParaRPr lang="en-US" dirty="0"/>
           </a:p>
@@ -13436,7 +13515,7 @@
           <a:p>
             <a:fld id="{F1EBDF3B-3FFA-684A-A22D-4B1A741ADF37}" type="datetime1">
               <a:rPr lang="en-US" smtClean="0"/>
-              <a:t>4/27/2026</a:t>
+              <a:t>4/28/2026</a:t>
             </a:fld>
             <a:endParaRPr lang="en-US" dirty="0"/>
           </a:p>
@@ -13660,7 +13739,7 @@
           <a:p>
             <a:fld id="{733EAEBE-CA61-5040-850D-8DDBD3B263E9}" type="datetime1">
               <a:rPr lang="en-US" smtClean="0"/>
-              <a:t>4/27/2026</a:t>
+              <a:t>4/28/2026</a:t>
             </a:fld>
             <a:endParaRPr lang="en-US" dirty="0"/>
           </a:p>
@@ -13883,7 +13962,7 @@
           <a:p>
             <a:fld id="{7AF4E7F1-F91F-AD4F-AC91-E9089FFC5F81}" type="datetime1">
               <a:rPr lang="en-US" smtClean="0"/>
-              <a:t>4/27/2026</a:t>
+              <a:t>4/28/2026</a:t>
             </a:fld>
             <a:endParaRPr lang="en-US" dirty="0"/>
           </a:p>
@@ -14098,7 +14177,7 @@
           <a:p>
             <a:fld id="{4293B5A0-0FC4-284F-8762-E74EE3523890}" type="datetime1">
               <a:rPr lang="en-US" smtClean="0"/>
-              <a:t>4/27/2026</a:t>
+              <a:t>4/28/2026</a:t>
             </a:fld>
             <a:endParaRPr lang="en-US" dirty="0"/>
           </a:p>
@@ -14410,7 +14489,7 @@
           <a:p>
             <a:fld id="{33F1578D-94A7-9E43-82B8-AAFA272825E2}" type="datetime1">
               <a:rPr lang="en-US" smtClean="0"/>
-              <a:t>4/27/2026</a:t>
+              <a:t>4/28/2026</a:t>
             </a:fld>
             <a:endParaRPr lang="en-US" dirty="0"/>
           </a:p>
@@ -14838,7 +14917,7 @@
           <a:p>
             <a:fld id="{7A9E3611-F589-6B46-B56A-435CF60591D4}" type="datetime1">
               <a:rPr lang="en-US" smtClean="0"/>
-              <a:t>4/27/2026</a:t>
+              <a:t>4/28/2026</a:t>
             </a:fld>
             <a:endParaRPr lang="en-US" dirty="0"/>
           </a:p>
@@ -14983,7 +15062,7 @@
           <a:p>
             <a:fld id="{EE4692AA-1C89-D34D-9E81-E1A863B5BE18}" type="datetime1">
               <a:rPr lang="en-US" smtClean="0"/>
-              <a:t>4/27/2026</a:t>
+              <a:t>4/28/2026</a:t>
             </a:fld>
             <a:endParaRPr lang="en-US" dirty="0"/>
           </a:p>
@@ -15212,7 +15291,7 @@
           <a:p>
             <a:fld id="{FEF188D7-4720-D141-81CC-740F79D50C31}" type="datetime1">
               <a:rPr lang="en-US" smtClean="0"/>
-              <a:t>4/27/2026</a:t>
+              <a:t>4/28/2026</a:t>
             </a:fld>
             <a:endParaRPr lang="en-US" dirty="0"/>
           </a:p>
@@ -15344,7 +15423,7 @@
           <a:p>
             <a:fld id="{BD42A457-1E7D-C84D-ACA4-D60564856941}" type="datetime1">
               <a:rPr lang="en-US" smtClean="0"/>
-              <a:t>4/27/2026</a:t>
+              <a:t>4/28/2026</a:t>
             </a:fld>
             <a:endParaRPr lang="en-US" dirty="0"/>
           </a:p>
@@ -15666,7 +15745,7 @@
           <a:p>
             <a:fld id="{CC971255-8A2A-504E-AE57-51186F2E75A8}" type="datetime1">
               <a:rPr lang="en-US" smtClean="0"/>
-              <a:t>4/27/2026</a:t>
+              <a:t>4/28/2026</a:t>
             </a:fld>
             <a:endParaRPr lang="en-US" dirty="0"/>
           </a:p>
@@ -15978,7 +16057,7 @@
           <a:p>
             <a:fld id="{53590A0A-7008-8A4A-B23F-5951DF641DB9}" type="datetime1">
               <a:rPr lang="en-US" smtClean="0"/>
-              <a:t>4/27/2026</a:t>
+              <a:t>4/28/2026</a:t>
             </a:fld>
             <a:endParaRPr lang="en-US" dirty="0"/>
           </a:p>
@@ -16250,7 +16329,7 @@
           <a:p>
             <a:fld id="{8D131EFE-56B6-8F4D-8113-558CEDB7B73A}" type="datetime1">
               <a:rPr lang="en-US" smtClean="0"/>
-              <a:t>4/27/2026</a:t>
+              <a:t>4/28/2026</a:t>
             </a:fld>
             <a:endParaRPr lang="en-US" dirty="0"/>
           </a:p>
@@ -16524,7 +16603,7 @@
           <a:p>
             <a:fld id="{6914D02D-3DC0-C54F-AF94-CB2AA6AB0D37}" type="datetime1">
               <a:rPr lang="en-US" smtClean="0"/>
-              <a:t>4/27/2026</a:t>
+              <a:t>4/28/2026</a:t>
             </a:fld>
             <a:endParaRPr lang="en-US" dirty="0"/>
           </a:p>
@@ -16812,7 +16891,7 @@
             <a:fld id="{6914D02D-3DC0-C54F-AF94-CB2AA6AB0D37}" type="datetime1">
               <a:rPr lang="en-US" smtClean="0"/>
               <a:pPr/>
-              <a:t>4/27/2026</a:t>
+              <a:t>4/28/2026</a:t>
             </a:fld>
             <a:endParaRPr lang="en-US" dirty="0"/>
           </a:p>
@@ -17288,7 +17367,7 @@
           <a:p>
             <a:fld id="{B6FDE768-21C6-CE4B-B654-E1D0DDCC05FD}" type="datetime1">
               <a:rPr lang="en-US" smtClean="0"/>
-              <a:t>4/27/2026</a:t>
+              <a:t>4/28/2026</a:t>
             </a:fld>
             <a:endParaRPr lang="en-US" dirty="0"/>
           </a:p>
@@ -17533,7 +17612,7 @@
           <a:p>
             <a:fld id="{5835D13D-5B61-AA42-A678-BA823C019B39}" type="datetime1">
               <a:rPr lang="en-US" smtClean="0"/>
-              <a:t>4/27/2026</a:t>
+              <a:t>4/28/2026</a:t>
             </a:fld>
             <a:endParaRPr lang="en-US" dirty="0"/>
           </a:p>
@@ -17816,7 +17895,7 @@
           <a:p>
             <a:fld id="{18F0419B-7218-144B-AE0A-3AE9A5E7F34E}" type="datetime1">
               <a:rPr lang="en-US" smtClean="0"/>
-              <a:t>4/27/2026</a:t>
+              <a:t>4/28/2026</a:t>
             </a:fld>
             <a:endParaRPr lang="en-US" dirty="0"/>
           </a:p>
@@ -18205,7 +18284,7 @@
           <a:p>
             <a:fld id="{111D9101-0A20-A644-B98A-5AAB72007147}" type="datetime1">
               <a:rPr lang="en-US" smtClean="0"/>
-              <a:t>4/27/2026</a:t>
+              <a:t>4/28/2026</a:t>
             </a:fld>
             <a:endParaRPr lang="en-US" dirty="0"/>
           </a:p>
@@ -18470,7 +18549,7 @@
             <a:fld id="{6A0A5BC3-F280-874C-BA55-1A6C5B1523D3}" type="datetime1">
               <a:rPr lang="en-US" smtClean="0"/>
               <a:pPr/>
-              <a:t>4/27/2026</a:t>
+              <a:t>4/28/2026</a:t>
             </a:fld>
             <a:endParaRPr lang="en-US" dirty="0"/>
           </a:p>
@@ -19066,19 +19145,20 @@
         </p:nvSpPr>
         <p:spPr>
           <a:xfrm>
-            <a:off x="657343" y="1001716"/>
-            <a:ext cx="4305184" cy="755658"/>
-          </a:xfrm>
-        </p:spPr>
-        <p:txBody>
-          <a:bodyPr/>
-          <a:lstStyle/>
-          <a:p>
-            <a:r>
-              <a:rPr lang="en-US"/>
-              <a:t>Our customers</a:t>
-            </a:r>
-            <a:endParaRPr lang="en-US" dirty="0"/>
+            <a:off x="219457" y="517084"/>
+            <a:ext cx="5203231" cy="755658"/>
+          </a:xfrm>
+        </p:spPr>
+        <p:txBody>
+          <a:bodyPr>
+            <a:normAutofit fontScale="90000"/>
+          </a:bodyPr>
+          <a:lstStyle/>
+          <a:p>
+            <a:r>
+              <a:rPr lang="en-US" dirty="0"/>
+              <a:t>Different colors have different behavioral effects</a:t>
+            </a:r>
           </a:p>
         </p:txBody>
       </p:sp>
@@ -19110,84 +19190,65 @@
           </a:bodyPr>
           <a:lstStyle/>
           <a:p>
-            <a:pPr marL="0" indent="0">
-              <a:buNone/>
-            </a:pPr>
-            <a:r>
-              <a:rPr lang="en-US" b="1"/>
-              <a:t>Key demographics</a:t>
-            </a:r>
-          </a:p>
-          <a:p>
-            <a:pPr marL="0" indent="0">
-              <a:buNone/>
-            </a:pPr>
-            <a:r>
-              <a:rPr lang="en-US"/>
-              <a:t>Understanding key demographics is crucial for tailoring successful marketing strategies. </a:t>
-            </a:r>
-            <a:br>
-              <a:rPr lang="en-US"/>
-            </a:br>
-            <a:br>
-              <a:rPr lang="en-US"/>
-            </a:br>
-            <a:r>
-              <a:rPr lang="en-US" b="1"/>
-              <a:t>Challenges &amp; needs</a:t>
-            </a:r>
-          </a:p>
-          <a:p>
-            <a:pPr marL="0" indent="0">
-              <a:buNone/>
-            </a:pPr>
-            <a:r>
-              <a:rPr lang="en-US"/>
-              <a:t>Our target audience faces several challenges and needs that our marketing strategies aim to address. </a:t>
-            </a:r>
-            <a:endParaRPr lang="en-US" dirty="0"/>
+            <a:r>
+              <a:rPr lang="en-US" dirty="0"/>
+              <a:t>Mostly driven by study 5</a:t>
+            </a:r>
+          </a:p>
+          <a:p>
+            <a:endParaRPr lang="en-US" dirty="0"/>
+          </a:p>
+          <a:p>
+            <a:r>
+              <a:rPr lang="en-US" dirty="0"/>
+              <a:t>White light most applicable across studies but contains multiple spectral peaks</a:t>
+            </a:r>
+          </a:p>
+          <a:p>
+            <a:endParaRPr lang="en-US" dirty="0"/>
+          </a:p>
+          <a:p>
+            <a:r>
+              <a:rPr lang="en-US" dirty="0"/>
+              <a:t>Activity result probably most reliable here</a:t>
+            </a:r>
           </a:p>
         </p:txBody>
       </p:sp>
       <p:pic>
         <p:nvPicPr>
-          <p:cNvPr id="9" name="Picture Placeholder 8" descr="A person typing on a computer">
-            <a:extLst>
-              <a:ext uri="{FF2B5EF4-FFF2-40B4-BE49-F238E27FC236}">
-                <a16:creationId xmlns:a16="http://schemas.microsoft.com/office/drawing/2014/main" id="{A0BE5B22-09A0-4CE1-DA06-CCCF03B7AA4F}"/>
+          <p:cNvPr id="7" name="Picture 6">
+            <a:extLst>
+              <a:ext uri="{FF2B5EF4-FFF2-40B4-BE49-F238E27FC236}">
+                <a16:creationId xmlns:a16="http://schemas.microsoft.com/office/drawing/2014/main" id="{C730BCD2-E744-5DD4-9970-862FC5A5343A}"/>
               </a:ext>
             </a:extLst>
           </p:cNvPr>
           <p:cNvPicPr>
-            <a:picLocks noGrp="1" noChangeAspect="1"/>
+            <a:picLocks noChangeAspect="1"/>
           </p:cNvPicPr>
-          <p:nvPr>
-            <p:ph type="pic" sz="quarter" idx="15"/>
-          </p:nvPr>
+          <p:nvPr/>
         </p:nvPicPr>
         <p:blipFill>
-          <a:blip r:embed="rId2" cstate="screen">
-            <a:duotone>
-              <a:prstClr val="black"/>
-              <a:srgbClr val="D9C3A5">
-                <a:tint val="50000"/>
-                <a:satMod val="180000"/>
-              </a:srgbClr>
-            </a:duotone>
+          <a:blip r:embed="rId2">
             <a:extLst>
               <a:ext uri="{28A0092B-C50C-407E-A947-70E740481C1C}">
-                <a14:useLocalDpi xmlns:a14="http://schemas.microsoft.com/office/drawing/2010/main"/>
+                <a14:useLocalDpi xmlns:a14="http://schemas.microsoft.com/office/drawing/2010/main" val="0"/>
               </a:ext>
             </a:extLst>
           </a:blip>
-          <a:srcRect/>
-          <a:stretch/>
+          <a:stretch>
+            <a:fillRect/>
+          </a:stretch>
         </p:blipFill>
         <p:spPr>
           <a:xfrm>
-            <a:off x="6263639" y="1493440"/>
-            <a:ext cx="5486400" cy="3867912"/>
-          </a:xfrm>
+            <a:off x="5976835" y="1531020"/>
+            <a:ext cx="6150860" cy="3795959"/>
+          </a:xfrm>
+          <a:prstGeom prst="rect">
+            <a:avLst/>
+          </a:prstGeom>
         </p:spPr>
       </p:pic>
     </p:spTree>
@@ -19250,980 +19311,184 @@
           <a:p>
             <a:r>
               <a:rPr lang="en-US" dirty="0"/>
-              <a:t>Marketing strategy</a:t>
-            </a:r>
-          </a:p>
-        </p:txBody>
-      </p:sp>
-      <p:graphicFrame>
-        <p:nvGraphicFramePr>
-          <p:cNvPr id="7" name="Content Placeholder 6">
-            <a:extLst>
-              <a:ext uri="{FF2B5EF4-FFF2-40B4-BE49-F238E27FC236}">
-                <a16:creationId xmlns:a16="http://schemas.microsoft.com/office/drawing/2014/main" id="{69780BEB-FFD1-3971-F361-1B40A8D66893}"/>
-              </a:ext>
-            </a:extLst>
-          </p:cNvPr>
-          <p:cNvGraphicFramePr>
-            <a:graphicFrameLocks noGrp="1"/>
-          </p:cNvGraphicFramePr>
+              <a:t>Future Directions &amp; Meta-regression</a:t>
+            </a:r>
+          </a:p>
+        </p:txBody>
+      </p:sp>
+      <p:pic>
+        <p:nvPicPr>
+          <p:cNvPr id="6" name="Content Placeholder 5">
+            <a:extLst>
+              <a:ext uri="{FF2B5EF4-FFF2-40B4-BE49-F238E27FC236}">
+                <a16:creationId xmlns:a16="http://schemas.microsoft.com/office/drawing/2014/main" id="{5FCF4C38-EC5E-C457-57DC-50696E24CDE0}"/>
+              </a:ext>
+            </a:extLst>
+          </p:cNvPr>
+          <p:cNvPicPr>
+            <a:picLocks noGrp="1" noChangeAspect="1"/>
+          </p:cNvPicPr>
           <p:nvPr>
             <p:ph idx="1"/>
-            <p:extLst>
-              <p:ext uri="{D42A27DB-BD31-4B8C-83A1-F6EECF244321}">
-                <p14:modId xmlns:p14="http://schemas.microsoft.com/office/powerpoint/2010/main" val="2715349785"/>
-              </p:ext>
-            </p:extLst>
-          </p:nvPr>
-        </p:nvGraphicFramePr>
-        <p:xfrm>
-          <a:off x="633413" y="2138363"/>
-          <a:ext cx="10923933" cy="4093525"/>
-        </p:xfrm>
-        <a:graphic>
-          <a:graphicData uri="http://schemas.openxmlformats.org/drawingml/2006/table">
-            <a:tbl>
-              <a:tblPr firstRow="1">
-                <a:tableStyleId>{0E3FDE45-AF77-4B5C-9715-49D594BDF05E}</a:tableStyleId>
-              </a:tblPr>
-              <a:tblGrid>
-                <a:gridCol w="3641311">
-                  <a:extLst>
-                    <a:ext uri="{9D8B030D-6E8A-4147-A177-3AD203B41FA5}">
-                      <a16:colId xmlns:a16="http://schemas.microsoft.com/office/drawing/2014/main" val="3168546316"/>
-                    </a:ext>
-                  </a:extLst>
-                </a:gridCol>
-                <a:gridCol w="3641311">
-                  <a:extLst>
-                    <a:ext uri="{9D8B030D-6E8A-4147-A177-3AD203B41FA5}">
-                      <a16:colId xmlns:a16="http://schemas.microsoft.com/office/drawing/2014/main" val="3249273269"/>
-                    </a:ext>
-                  </a:extLst>
-                </a:gridCol>
-                <a:gridCol w="3641311">
-                  <a:extLst>
-                    <a:ext uri="{9D8B030D-6E8A-4147-A177-3AD203B41FA5}">
-                      <a16:colId xmlns:a16="http://schemas.microsoft.com/office/drawing/2014/main" val="2175169288"/>
-                    </a:ext>
-                  </a:extLst>
-                </a:gridCol>
-              </a:tblGrid>
-              <a:tr h="818705">
-                <a:tc>
-                  <a:txBody>
-                    <a:bodyPr/>
-                    <a:lstStyle/>
-                    <a:p>
-                      <a:r>
-                        <a:rPr lang="en-US" sz="1600" b="0" dirty="0">
-                          <a:solidFill>
-                            <a:schemeClr val="accent2"/>
-                          </a:solidFill>
-                          <a:latin typeface="+mj-lt"/>
-                        </a:rPr>
-                        <a:t>Focus area</a:t>
-                      </a:r>
-                      <a:endParaRPr lang="en-US" sz="1600" b="0" i="0" dirty="0">
-                        <a:solidFill>
-                          <a:schemeClr val="accent2"/>
-                        </a:solidFill>
-                        <a:latin typeface="+mj-lt"/>
-                      </a:endParaRPr>
-                    </a:p>
-                  </a:txBody>
-                  <a:tcPr anchor="ctr"/>
-                </a:tc>
-                <a:tc>
-                  <a:txBody>
-                    <a:bodyPr/>
-                    <a:lstStyle/>
-                    <a:p>
-                      <a:r>
-                        <a:rPr lang="en-US" sz="1600" b="0" dirty="0">
-                          <a:solidFill>
-                            <a:schemeClr val="accent2"/>
-                          </a:solidFill>
-                          <a:latin typeface="+mj-lt"/>
-                        </a:rPr>
-                        <a:t>Approach</a:t>
-                      </a:r>
-                      <a:endParaRPr lang="en-US" sz="1600" b="0" i="0" dirty="0">
-                        <a:solidFill>
-                          <a:schemeClr val="accent2"/>
-                        </a:solidFill>
-                        <a:latin typeface="+mj-lt"/>
-                      </a:endParaRPr>
-                    </a:p>
-                  </a:txBody>
-                  <a:tcPr anchor="ctr"/>
-                </a:tc>
-                <a:tc>
-                  <a:txBody>
-                    <a:bodyPr/>
-                    <a:lstStyle/>
-                    <a:p>
-                      <a:r>
-                        <a:rPr lang="en-US" sz="1600" b="0" dirty="0">
-                          <a:solidFill>
-                            <a:schemeClr val="accent2"/>
-                          </a:solidFill>
-                          <a:latin typeface="+mj-lt"/>
-                        </a:rPr>
-                        <a:t>Goal</a:t>
-                      </a:r>
-                      <a:endParaRPr lang="en-US" sz="1600" b="0" i="0" dirty="0">
-                        <a:solidFill>
-                          <a:schemeClr val="accent2"/>
-                        </a:solidFill>
-                        <a:latin typeface="+mj-lt"/>
-                      </a:endParaRPr>
-                    </a:p>
-                  </a:txBody>
-                  <a:tcPr anchor="ctr"/>
-                </a:tc>
-                <a:extLst>
-                  <a:ext uri="{0D108BD9-81ED-4DB2-BD59-A6C34878D82A}">
-                    <a16:rowId xmlns:a16="http://schemas.microsoft.com/office/drawing/2014/main" val="3364231172"/>
-                  </a:ext>
-                </a:extLst>
-              </a:tr>
-              <a:tr h="818705">
-                <a:tc>
-                  <a:txBody>
-                    <a:bodyPr/>
-                    <a:lstStyle/>
-                    <a:p>
-                      <a:r>
-                        <a:rPr lang="en-US" sz="1600" b="0" dirty="0">
-                          <a:solidFill>
-                            <a:schemeClr val="accent2"/>
-                          </a:solidFill>
-                          <a:latin typeface="+mn-lt"/>
-                        </a:rPr>
-                        <a:t>Brand awareness</a:t>
-                      </a:r>
-                      <a:endParaRPr lang="en-US" sz="1600" b="0" i="0" dirty="0">
-                        <a:solidFill>
-                          <a:schemeClr val="accent2"/>
-                        </a:solidFill>
-                        <a:latin typeface="+mn-lt"/>
-                      </a:endParaRPr>
-                    </a:p>
-                  </a:txBody>
-                  <a:tcPr anchor="ctr"/>
-                </a:tc>
-                <a:tc>
-                  <a:txBody>
-                    <a:bodyPr/>
-                    <a:lstStyle/>
-                    <a:p>
-                      <a:r>
-                        <a:rPr lang="en-US" sz="1600" b="0" dirty="0">
-                          <a:solidFill>
-                            <a:schemeClr val="accent2"/>
-                          </a:solidFill>
-                          <a:latin typeface="+mn-lt"/>
-                        </a:rPr>
-                        <a:t>Social media campaigns</a:t>
-                      </a:r>
-                      <a:endParaRPr lang="en-US" sz="1600" b="0" i="0" dirty="0">
-                        <a:solidFill>
-                          <a:schemeClr val="accent2"/>
-                        </a:solidFill>
-                        <a:latin typeface="+mn-lt"/>
-                      </a:endParaRPr>
-                    </a:p>
-                  </a:txBody>
-                  <a:tcPr anchor="ctr"/>
-                </a:tc>
-                <a:tc>
-                  <a:txBody>
-                    <a:bodyPr/>
-                    <a:lstStyle/>
-                    <a:p>
-                      <a:r>
-                        <a:rPr lang="en-US" sz="1600" b="0" dirty="0">
-                          <a:solidFill>
-                            <a:schemeClr val="accent2"/>
-                          </a:solidFill>
-                          <a:latin typeface="+mn-lt"/>
-                        </a:rPr>
-                        <a:t>Increase engagement by 30%</a:t>
-                      </a:r>
-                      <a:endParaRPr lang="en-US" sz="1600" b="0" i="0" dirty="0">
-                        <a:solidFill>
-                          <a:schemeClr val="accent2"/>
-                        </a:solidFill>
-                        <a:latin typeface="+mn-lt"/>
-                      </a:endParaRPr>
-                    </a:p>
-                  </a:txBody>
-                  <a:tcPr anchor="ctr"/>
-                </a:tc>
-                <a:extLst>
-                  <a:ext uri="{0D108BD9-81ED-4DB2-BD59-A6C34878D82A}">
-                    <a16:rowId xmlns:a16="http://schemas.microsoft.com/office/drawing/2014/main" val="3559441191"/>
-                  </a:ext>
-                </a:extLst>
-              </a:tr>
-              <a:tr h="818705">
-                <a:tc>
-                  <a:txBody>
-                    <a:bodyPr/>
-                    <a:lstStyle/>
-                    <a:p>
-                      <a:r>
-                        <a:rPr lang="en-US" sz="1600" b="0" dirty="0">
-                          <a:solidFill>
-                            <a:schemeClr val="accent2"/>
-                          </a:solidFill>
-                          <a:latin typeface="+mn-lt"/>
-                        </a:rPr>
-                        <a:t>Lead generation</a:t>
-                      </a:r>
-                      <a:endParaRPr lang="en-US" sz="1600" b="0" i="0" dirty="0">
-                        <a:solidFill>
-                          <a:schemeClr val="accent2"/>
-                        </a:solidFill>
-                        <a:latin typeface="+mn-lt"/>
-                      </a:endParaRPr>
-                    </a:p>
-                  </a:txBody>
-                  <a:tcPr anchor="ctr"/>
-                </a:tc>
-                <a:tc>
-                  <a:txBody>
-                    <a:bodyPr/>
-                    <a:lstStyle/>
-                    <a:p>
-                      <a:r>
-                        <a:rPr lang="en-US" sz="1600" b="0" dirty="0">
-                          <a:solidFill>
-                            <a:schemeClr val="accent2"/>
-                          </a:solidFill>
-                          <a:latin typeface="+mn-lt"/>
-                        </a:rPr>
-                        <a:t>Email marketing &amp; PPC</a:t>
-                      </a:r>
-                      <a:endParaRPr lang="en-US" sz="1600" b="0" i="0" dirty="0">
-                        <a:solidFill>
-                          <a:schemeClr val="accent2"/>
-                        </a:solidFill>
-                        <a:latin typeface="+mn-lt"/>
-                      </a:endParaRPr>
-                    </a:p>
-                  </a:txBody>
-                  <a:tcPr anchor="ctr"/>
-                </a:tc>
-                <a:tc>
-                  <a:txBody>
-                    <a:bodyPr/>
-                    <a:lstStyle/>
-                    <a:p>
-                      <a:r>
-                        <a:rPr lang="en-US" sz="1600" b="0" dirty="0">
-                          <a:solidFill>
-                            <a:schemeClr val="accent2"/>
-                          </a:solidFill>
-                          <a:latin typeface="+mn-lt"/>
-                        </a:rPr>
-                        <a:t>Grow qualified leads by 20%</a:t>
-                      </a:r>
-                      <a:endParaRPr lang="en-US" sz="1600" b="0" i="0" dirty="0">
-                        <a:solidFill>
-                          <a:schemeClr val="accent2"/>
-                        </a:solidFill>
-                        <a:latin typeface="+mn-lt"/>
-                      </a:endParaRPr>
-                    </a:p>
-                  </a:txBody>
-                  <a:tcPr anchor="ctr"/>
-                </a:tc>
-                <a:extLst>
-                  <a:ext uri="{0D108BD9-81ED-4DB2-BD59-A6C34878D82A}">
-                    <a16:rowId xmlns:a16="http://schemas.microsoft.com/office/drawing/2014/main" val="1425558636"/>
-                  </a:ext>
-                </a:extLst>
-              </a:tr>
-              <a:tr h="818705">
-                <a:tc>
-                  <a:txBody>
-                    <a:bodyPr/>
-                    <a:lstStyle/>
-                    <a:p>
-                      <a:r>
-                        <a:rPr lang="en-US" sz="1600" b="0" dirty="0">
-                          <a:solidFill>
-                            <a:schemeClr val="accent2"/>
-                          </a:solidFill>
-                          <a:latin typeface="+mn-lt"/>
-                        </a:rPr>
-                        <a:t>Customer retention</a:t>
-                      </a:r>
-                      <a:endParaRPr lang="en-US" sz="1600" b="0" i="0" dirty="0">
-                        <a:solidFill>
-                          <a:schemeClr val="accent2"/>
-                        </a:solidFill>
-                        <a:latin typeface="+mn-lt"/>
-                      </a:endParaRPr>
-                    </a:p>
-                  </a:txBody>
-                  <a:tcPr anchor="ctr"/>
-                </a:tc>
-                <a:tc>
-                  <a:txBody>
-                    <a:bodyPr/>
-                    <a:lstStyle/>
-                    <a:p>
-                      <a:r>
-                        <a:rPr lang="en-US" sz="1600" b="0" dirty="0">
-                          <a:solidFill>
-                            <a:schemeClr val="accent2"/>
-                          </a:solidFill>
-                          <a:latin typeface="+mn-lt"/>
-                        </a:rPr>
-                        <a:t>Loyalty programs, automation</a:t>
-                      </a:r>
-                      <a:endParaRPr lang="en-US" sz="1600" b="0" i="0" dirty="0">
-                        <a:solidFill>
-                          <a:schemeClr val="accent2"/>
-                        </a:solidFill>
-                        <a:latin typeface="+mn-lt"/>
-                      </a:endParaRPr>
-                    </a:p>
-                  </a:txBody>
-                  <a:tcPr anchor="ctr"/>
-                </a:tc>
-                <a:tc>
-                  <a:txBody>
-                    <a:bodyPr/>
-                    <a:lstStyle/>
-                    <a:p>
-                      <a:r>
-                        <a:rPr lang="en-US" sz="1600" b="0" dirty="0">
-                          <a:solidFill>
-                            <a:schemeClr val="accent2"/>
-                          </a:solidFill>
-                          <a:latin typeface="+mn-lt"/>
-                        </a:rPr>
-                        <a:t>Boost purchases</a:t>
-                      </a:r>
-                      <a:endParaRPr lang="en-US" sz="1600" b="0" i="0" dirty="0">
-                        <a:solidFill>
-                          <a:schemeClr val="accent2"/>
-                        </a:solidFill>
-                        <a:latin typeface="+mn-lt"/>
-                      </a:endParaRPr>
-                    </a:p>
-                  </a:txBody>
-                  <a:tcPr anchor="ctr"/>
-                </a:tc>
-                <a:extLst>
-                  <a:ext uri="{0D108BD9-81ED-4DB2-BD59-A6C34878D82A}">
-                    <a16:rowId xmlns:a16="http://schemas.microsoft.com/office/drawing/2014/main" val="1609158448"/>
-                  </a:ext>
-                </a:extLst>
-              </a:tr>
-              <a:tr h="818705">
-                <a:tc>
-                  <a:txBody>
-                    <a:bodyPr/>
-                    <a:lstStyle/>
-                    <a:p>
-                      <a:r>
-                        <a:rPr lang="en-US" sz="1600" b="0" dirty="0">
-                          <a:solidFill>
-                            <a:schemeClr val="accent2"/>
-                          </a:solidFill>
-                          <a:latin typeface="+mn-lt"/>
-                        </a:rPr>
-                        <a:t>Content marketing</a:t>
-                      </a:r>
-                      <a:endParaRPr lang="en-US" sz="1600" b="0" i="0" dirty="0">
-                        <a:solidFill>
-                          <a:schemeClr val="accent2"/>
-                        </a:solidFill>
-                        <a:latin typeface="+mn-lt"/>
-                      </a:endParaRPr>
-                    </a:p>
-                  </a:txBody>
-                  <a:tcPr anchor="ctr"/>
-                </a:tc>
-                <a:tc>
-                  <a:txBody>
-                    <a:bodyPr/>
-                    <a:lstStyle/>
-                    <a:p>
-                      <a:r>
-                        <a:rPr lang="en-US" sz="1600" b="0" dirty="0">
-                          <a:solidFill>
-                            <a:schemeClr val="accent2"/>
-                          </a:solidFill>
-                          <a:latin typeface="+mn-lt"/>
-                        </a:rPr>
-                        <a:t>SEO optimized short-form videos</a:t>
-                      </a:r>
-                      <a:endParaRPr lang="en-US" sz="1600" b="0" i="0" dirty="0">
-                        <a:solidFill>
-                          <a:schemeClr val="accent2"/>
-                        </a:solidFill>
-                        <a:latin typeface="+mn-lt"/>
-                      </a:endParaRPr>
-                    </a:p>
-                  </a:txBody>
-                  <a:tcPr anchor="ctr"/>
-                </a:tc>
-                <a:tc>
-                  <a:txBody>
-                    <a:bodyPr/>
-                    <a:lstStyle/>
-                    <a:p>
-                      <a:r>
-                        <a:rPr lang="en-US" sz="1600" b="0" dirty="0">
-                          <a:solidFill>
-                            <a:schemeClr val="accent2"/>
-                          </a:solidFill>
-                          <a:latin typeface="+mn-lt"/>
-                        </a:rPr>
-                        <a:t>Improve organic reach</a:t>
-                      </a:r>
-                      <a:endParaRPr lang="en-US" sz="1600" b="0" i="0" dirty="0">
-                        <a:solidFill>
-                          <a:schemeClr val="accent2"/>
-                        </a:solidFill>
-                        <a:latin typeface="+mn-lt"/>
-                      </a:endParaRPr>
-                    </a:p>
-                  </a:txBody>
-                  <a:tcPr anchor="ctr"/>
-                </a:tc>
-                <a:extLst>
-                  <a:ext uri="{0D108BD9-81ED-4DB2-BD59-A6C34878D82A}">
-                    <a16:rowId xmlns:a16="http://schemas.microsoft.com/office/drawing/2014/main" val="3142950618"/>
-                  </a:ext>
-                </a:extLst>
-              </a:tr>
-            </a:tbl>
-          </a:graphicData>
-        </a:graphic>
-      </p:graphicFrame>
+          </p:nvPr>
+        </p:nvPicPr>
+        <p:blipFill>
+          <a:blip r:embed="rId2">
+            <a:extLst>
+              <a:ext uri="{28A0092B-C50C-407E-A947-70E740481C1C}">
+                <a14:useLocalDpi xmlns:a14="http://schemas.microsoft.com/office/drawing/2010/main" val="0"/>
+              </a:ext>
+            </a:extLst>
+          </a:blip>
+          <a:stretch>
+            <a:fillRect/>
+          </a:stretch>
+        </p:blipFill>
+        <p:spPr>
+          <a:xfrm>
+            <a:off x="6355047" y="2385192"/>
+            <a:ext cx="5514056" cy="3402960"/>
+          </a:xfrm>
+          <a:prstGeom prst="rect">
+            <a:avLst/>
+          </a:prstGeom>
+        </p:spPr>
+      </p:pic>
+      <p:sp>
+        <p:nvSpPr>
+          <p:cNvPr id="8" name="TextBox 7">
+            <a:extLst>
+              <a:ext uri="{FF2B5EF4-FFF2-40B4-BE49-F238E27FC236}">
+                <a16:creationId xmlns:a16="http://schemas.microsoft.com/office/drawing/2014/main" id="{A3A1B24F-5D0E-4DF5-CCB3-520DB7261C5C}"/>
+              </a:ext>
+            </a:extLst>
+          </p:cNvPr>
+          <p:cNvSpPr txBox="1"/>
+          <p:nvPr/>
+        </p:nvSpPr>
+        <p:spPr>
+          <a:xfrm>
+            <a:off x="6574536" y="2015860"/>
+            <a:ext cx="3378617" cy="369332"/>
+          </a:xfrm>
+          <a:prstGeom prst="rect">
+            <a:avLst/>
+          </a:prstGeom>
+          <a:noFill/>
+        </p:spPr>
+        <p:txBody>
+          <a:bodyPr wrap="none" rtlCol="0">
+            <a:spAutoFit/>
+          </a:bodyPr>
+          <a:lstStyle/>
+          <a:p>
+            <a:r>
+              <a:rPr lang="en-US" dirty="0"/>
+              <a:t>Very preliminary meta-regression</a:t>
+            </a:r>
+          </a:p>
+        </p:txBody>
+      </p:sp>
+      <p:sp>
+        <p:nvSpPr>
+          <p:cNvPr id="9" name="TextBox 8">
+            <a:extLst>
+              <a:ext uri="{FF2B5EF4-FFF2-40B4-BE49-F238E27FC236}">
+                <a16:creationId xmlns:a16="http://schemas.microsoft.com/office/drawing/2014/main" id="{0614A91E-673C-5564-9F69-D58884C48C74}"/>
+              </a:ext>
+            </a:extLst>
+          </p:cNvPr>
+          <p:cNvSpPr txBox="1"/>
+          <p:nvPr/>
+        </p:nvSpPr>
+        <p:spPr>
+          <a:xfrm>
+            <a:off x="634030" y="2385192"/>
+            <a:ext cx="4706673" cy="2585323"/>
+          </a:xfrm>
+          <a:prstGeom prst="rect">
+            <a:avLst/>
+          </a:prstGeom>
+          <a:noFill/>
+        </p:spPr>
+        <p:txBody>
+          <a:bodyPr wrap="none" rtlCol="0">
+            <a:spAutoFit/>
+          </a:bodyPr>
+          <a:lstStyle/>
+          <a:p>
+            <a:pPr marL="285750" indent="-285750">
+              <a:buFont typeface="Arial" panose="020B0604020202020204" pitchFamily="34" charset="0"/>
+              <a:buChar char="•"/>
+            </a:pPr>
+            <a:r>
+              <a:rPr lang="en-US" sz="2400" dirty="0"/>
+              <a:t>Include more moderators</a:t>
+            </a:r>
+          </a:p>
+          <a:p>
+            <a:pPr marL="285750" indent="-285750">
+              <a:buFont typeface="Arial" panose="020B0604020202020204" pitchFamily="34" charset="0"/>
+              <a:buChar char="•"/>
+            </a:pPr>
+            <a:r>
+              <a:rPr lang="en-US" sz="2400" dirty="0"/>
+              <a:t>Calculate ln(CVR) variation</a:t>
+            </a:r>
+          </a:p>
+          <a:p>
+            <a:pPr marL="285750" indent="-285750">
+              <a:buFont typeface="Arial" panose="020B0604020202020204" pitchFamily="34" charset="0"/>
+              <a:buChar char="•"/>
+            </a:pPr>
+            <a:r>
+              <a:rPr lang="en-US" sz="2400" dirty="0"/>
+              <a:t>Perform actual meta-regressions</a:t>
+            </a:r>
+          </a:p>
+          <a:p>
+            <a:pPr marL="285750" indent="-285750">
+              <a:buFont typeface="Arial" panose="020B0604020202020204" pitchFamily="34" charset="0"/>
+              <a:buChar char="•"/>
+            </a:pPr>
+            <a:r>
+              <a:rPr lang="en-US" sz="2400" dirty="0"/>
+              <a:t>Improve search criterion</a:t>
+            </a:r>
+          </a:p>
+          <a:p>
+            <a:pPr marL="285750" indent="-285750">
+              <a:buFont typeface="Arial" panose="020B0604020202020204" pitchFamily="34" charset="0"/>
+              <a:buChar char="•"/>
+            </a:pPr>
+            <a:r>
+              <a:rPr lang="en-US" sz="2400" dirty="0"/>
+              <a:t>Run sensitivity analyses</a:t>
+            </a:r>
+          </a:p>
+          <a:p>
+            <a:pPr marL="285750" indent="-285750">
+              <a:buFont typeface="Arial" panose="020B0604020202020204" pitchFamily="34" charset="0"/>
+              <a:buChar char="•"/>
+            </a:pPr>
+            <a:r>
+              <a:rPr lang="en-US" sz="2400" dirty="0"/>
+              <a:t>Test publication bias</a:t>
+            </a:r>
+          </a:p>
+          <a:p>
+            <a:pPr marL="285750" indent="-285750">
+              <a:buFont typeface="Arial" panose="020B0604020202020204" pitchFamily="34" charset="0"/>
+              <a:buChar char="•"/>
+            </a:pPr>
+            <a:endParaRPr lang="en-US" dirty="0"/>
+          </a:p>
+        </p:txBody>
+      </p:sp>
     </p:spTree>
     <p:extLst>
       <p:ext uri="{BB962C8B-B14F-4D97-AF65-F5344CB8AC3E}">
         <p14:creationId xmlns:p14="http://schemas.microsoft.com/office/powerpoint/2010/main" val="1135043495"/>
-      </p:ext>
-    </p:extLst>
-  </p:cSld>
-  <p:clrMapOvr>
-    <a:masterClrMapping/>
-  </p:clrMapOvr>
-</p:sld>
-</file>
-
-<file path=ppt/slides/slide12.xml><?xml version="1.0" encoding="utf-8"?>
-<p:sld xmlns:a="http://schemas.openxmlformats.org/drawingml/2006/main" xmlns:r="http://schemas.openxmlformats.org/officeDocument/2006/relationships" xmlns:p="http://schemas.openxmlformats.org/presentationml/2006/main">
-  <p:cSld>
-    <p:spTree>
-      <p:nvGrpSpPr>
-        <p:cNvPr id="1" name=""/>
-        <p:cNvGrpSpPr/>
-        <p:nvPr/>
-      </p:nvGrpSpPr>
-      <p:grpSpPr>
-        <a:xfrm>
-          <a:off x="0" y="0"/>
-          <a:ext cx="0" cy="0"/>
-          <a:chOff x="0" y="0"/>
-          <a:chExt cx="0" cy="0"/>
-        </a:xfrm>
-      </p:grpSpPr>
-      <p:sp>
-        <p:nvSpPr>
-          <p:cNvPr id="2" name="Title 1">
-            <a:extLst>
-              <a:ext uri="{FF2B5EF4-FFF2-40B4-BE49-F238E27FC236}">
-                <a16:creationId xmlns:a16="http://schemas.microsoft.com/office/drawing/2014/main" id="{06B47223-A893-96A6-F0E7-83F317B9BE5B}"/>
-              </a:ext>
-            </a:extLst>
-          </p:cNvPr>
-          <p:cNvSpPr>
-            <a:spLocks noGrp="1"/>
-          </p:cNvSpPr>
-          <p:nvPr>
-            <p:ph type="ctrTitle"/>
-          </p:nvPr>
-        </p:nvSpPr>
-        <p:spPr>
-          <a:xfrm>
-            <a:off x="634030" y="1748474"/>
-            <a:ext cx="4714880" cy="4622443"/>
-          </a:xfrm>
-        </p:spPr>
-        <p:txBody>
-          <a:bodyPr/>
-          <a:lstStyle/>
-          <a:p>
-            <a:r>
-              <a:rPr lang="en-US" dirty="0"/>
-              <a:t>Marketing mix: </a:t>
-            </a:r>
-            <a:br>
-              <a:rPr lang="en-US" dirty="0"/>
-            </a:br>
-            <a:r>
-              <a:rPr lang="en-US" dirty="0"/>
-              <a:t>The 4 Ps</a:t>
-            </a:r>
-          </a:p>
-        </p:txBody>
-      </p:sp>
-    </p:spTree>
-    <p:extLst>
-      <p:ext uri="{BB962C8B-B14F-4D97-AF65-F5344CB8AC3E}">
-        <p14:creationId xmlns:p14="http://schemas.microsoft.com/office/powerpoint/2010/main" val="3761678752"/>
-      </p:ext>
-    </p:extLst>
-  </p:cSld>
-  <p:clrMapOvr>
-    <a:masterClrMapping/>
-  </p:clrMapOvr>
-</p:sld>
-</file>
-
-<file path=ppt/slides/slide13.xml><?xml version="1.0" encoding="utf-8"?>
-<p:sld xmlns:a="http://schemas.openxmlformats.org/drawingml/2006/main" xmlns:r="http://schemas.openxmlformats.org/officeDocument/2006/relationships" xmlns:p="http://schemas.openxmlformats.org/presentationml/2006/main">
-  <p:cSld>
-    <p:spTree>
-      <p:nvGrpSpPr>
-        <p:cNvPr id="1" name=""/>
-        <p:cNvGrpSpPr/>
-        <p:nvPr/>
-      </p:nvGrpSpPr>
-      <p:grpSpPr>
-        <a:xfrm>
-          <a:off x="0" y="0"/>
-          <a:ext cx="0" cy="0"/>
-          <a:chOff x="0" y="0"/>
-          <a:chExt cx="0" cy="0"/>
-        </a:xfrm>
-      </p:grpSpPr>
-      <p:sp>
-        <p:nvSpPr>
-          <p:cNvPr id="2" name="Title 1">
-            <a:extLst>
-              <a:ext uri="{FF2B5EF4-FFF2-40B4-BE49-F238E27FC236}">
-                <a16:creationId xmlns:a16="http://schemas.microsoft.com/office/drawing/2014/main" id="{9A819718-8129-CB4A-5FDF-3999F3BE8E83}"/>
-              </a:ext>
-            </a:extLst>
-          </p:cNvPr>
-          <p:cNvSpPr>
-            <a:spLocks noGrp="1"/>
-          </p:cNvSpPr>
-          <p:nvPr>
-            <p:ph type="title"/>
-          </p:nvPr>
-        </p:nvSpPr>
-        <p:spPr>
-          <a:xfrm>
-            <a:off x="634024" y="4800600"/>
-            <a:ext cx="10923934" cy="1422400"/>
-          </a:xfrm>
-        </p:spPr>
-        <p:txBody>
-          <a:bodyPr>
-            <a:normAutofit/>
-          </a:bodyPr>
-          <a:lstStyle/>
-          <a:p>
-            <a:r>
-              <a:rPr lang="en-US" dirty="0"/>
-              <a:t>increase in conversion rates through recent marketing efforts</a:t>
-            </a:r>
-          </a:p>
-        </p:txBody>
-      </p:sp>
-      <p:sp>
-        <p:nvSpPr>
-          <p:cNvPr id="3" name="Content Placeholder 2">
-            <a:extLst>
-              <a:ext uri="{FF2B5EF4-FFF2-40B4-BE49-F238E27FC236}">
-                <a16:creationId xmlns:a16="http://schemas.microsoft.com/office/drawing/2014/main" id="{348B4907-4194-55BC-BDE9-CCF6DAB2201B}"/>
-              </a:ext>
-            </a:extLst>
-          </p:cNvPr>
-          <p:cNvSpPr>
-            <a:spLocks noGrp="1"/>
-          </p:cNvSpPr>
-          <p:nvPr>
-            <p:ph sz="quarter" idx="13"/>
-          </p:nvPr>
-        </p:nvSpPr>
-        <p:spPr>
-          <a:xfrm>
-            <a:off x="634030" y="634998"/>
-            <a:ext cx="10923934" cy="4609355"/>
-          </a:xfrm>
-        </p:spPr>
-        <p:txBody>
-          <a:bodyPr/>
-          <a:lstStyle/>
-          <a:p>
-            <a:r>
-              <a:rPr lang="en-US" dirty="0"/>
-              <a:t>28%</a:t>
-            </a:r>
-          </a:p>
-        </p:txBody>
-      </p:sp>
-    </p:spTree>
-    <p:extLst>
-      <p:ext uri="{BB962C8B-B14F-4D97-AF65-F5344CB8AC3E}">
-        <p14:creationId xmlns:p14="http://schemas.microsoft.com/office/powerpoint/2010/main" val="3902066237"/>
-      </p:ext>
-    </p:extLst>
-  </p:cSld>
-  <p:clrMapOvr>
-    <a:masterClrMapping/>
-  </p:clrMapOvr>
-</p:sld>
-</file>
-
-<file path=ppt/slides/slide14.xml><?xml version="1.0" encoding="utf-8"?>
-<p:sld xmlns:a="http://schemas.openxmlformats.org/drawingml/2006/main" xmlns:r="http://schemas.openxmlformats.org/officeDocument/2006/relationships" xmlns:p="http://schemas.openxmlformats.org/presentationml/2006/main">
-  <p:cSld>
-    <p:spTree>
-      <p:nvGrpSpPr>
-        <p:cNvPr id="1" name=""/>
-        <p:cNvGrpSpPr/>
-        <p:nvPr/>
-      </p:nvGrpSpPr>
-      <p:grpSpPr>
-        <a:xfrm>
-          <a:off x="0" y="0"/>
-          <a:ext cx="0" cy="0"/>
-          <a:chOff x="0" y="0"/>
-          <a:chExt cx="0" cy="0"/>
-        </a:xfrm>
-      </p:grpSpPr>
-      <p:sp>
-        <p:nvSpPr>
-          <p:cNvPr id="2" name="Title 1">
-            <a:extLst>
-              <a:ext uri="{FF2B5EF4-FFF2-40B4-BE49-F238E27FC236}">
-                <a16:creationId xmlns:a16="http://schemas.microsoft.com/office/drawing/2014/main" id="{6159B732-B1AC-BE34-4B6A-E40D4AAEC4AE}"/>
-              </a:ext>
-            </a:extLst>
-          </p:cNvPr>
-          <p:cNvSpPr>
-            <a:spLocks noGrp="1"/>
-          </p:cNvSpPr>
-          <p:nvPr>
-            <p:ph type="title"/>
-          </p:nvPr>
-        </p:nvSpPr>
-        <p:spPr>
-          <a:xfrm>
-            <a:off x="634030" y="634999"/>
-            <a:ext cx="10923934" cy="375615"/>
-          </a:xfrm>
-        </p:spPr>
-        <p:txBody>
-          <a:bodyPr>
-            <a:noAutofit/>
-          </a:bodyPr>
-          <a:lstStyle/>
-          <a:p>
-            <a:r>
-              <a:rPr lang="en-US" dirty="0"/>
-              <a:t>Ana Bowman</a:t>
-            </a:r>
-            <a:r>
-              <a:rPr lang="en-US" b="0" dirty="0"/>
-              <a:t>, Director of Marketing</a:t>
-            </a:r>
-          </a:p>
-        </p:txBody>
-      </p:sp>
-      <p:sp>
-        <p:nvSpPr>
-          <p:cNvPr id="3" name="Content Placeholder 2">
-            <a:extLst>
-              <a:ext uri="{FF2B5EF4-FFF2-40B4-BE49-F238E27FC236}">
-                <a16:creationId xmlns:a16="http://schemas.microsoft.com/office/drawing/2014/main" id="{3F013921-0C7A-69E8-FDAD-099AB8A05415}"/>
-              </a:ext>
-            </a:extLst>
-          </p:cNvPr>
-          <p:cNvSpPr>
-            <a:spLocks noGrp="1"/>
-          </p:cNvSpPr>
-          <p:nvPr>
-            <p:ph sz="quarter" idx="13"/>
-          </p:nvPr>
-        </p:nvSpPr>
-        <p:spPr>
-          <a:xfrm>
-            <a:off x="634030" y="1748474"/>
-            <a:ext cx="10923934" cy="4474526"/>
-          </a:xfrm>
-        </p:spPr>
-        <p:txBody>
-          <a:bodyPr>
-            <a:normAutofit/>
-          </a:bodyPr>
-          <a:lstStyle/>
-          <a:p>
-            <a:r>
-              <a:rPr lang="en-US" dirty="0"/>
-              <a:t>“Our latest campaign drove a 35% increase in engagement, proving that strategic storytelling resonates.”</a:t>
-            </a:r>
-          </a:p>
-        </p:txBody>
-      </p:sp>
-    </p:spTree>
-    <p:extLst>
-      <p:ext uri="{BB962C8B-B14F-4D97-AF65-F5344CB8AC3E}">
-        <p14:creationId xmlns:p14="http://schemas.microsoft.com/office/powerpoint/2010/main" val="611099963"/>
-      </p:ext>
-    </p:extLst>
-  </p:cSld>
-  <p:clrMapOvr>
-    <a:masterClrMapping/>
-  </p:clrMapOvr>
-</p:sld>
-</file>
-
-<file path=ppt/slides/slide15.xml><?xml version="1.0" encoding="utf-8"?>
-<p:sld xmlns:a="http://schemas.openxmlformats.org/drawingml/2006/main" xmlns:r="http://schemas.openxmlformats.org/officeDocument/2006/relationships" xmlns:p="http://schemas.openxmlformats.org/presentationml/2006/main">
-  <p:cSld>
-    <p:spTree>
-      <p:nvGrpSpPr>
-        <p:cNvPr id="1" name=""/>
-        <p:cNvGrpSpPr/>
-        <p:nvPr/>
-      </p:nvGrpSpPr>
-      <p:grpSpPr>
-        <a:xfrm>
-          <a:off x="0" y="0"/>
-          <a:ext cx="0" cy="0"/>
-          <a:chOff x="0" y="0"/>
-          <a:chExt cx="0" cy="0"/>
-        </a:xfrm>
-      </p:grpSpPr>
-      <p:sp>
-        <p:nvSpPr>
-          <p:cNvPr id="2" name="Title 1">
-            <a:extLst>
-              <a:ext uri="{FF2B5EF4-FFF2-40B4-BE49-F238E27FC236}">
-                <a16:creationId xmlns:a16="http://schemas.microsoft.com/office/drawing/2014/main" id="{75676E2C-040E-4D92-F9F7-F61C47F4F152}"/>
-              </a:ext>
-            </a:extLst>
-          </p:cNvPr>
-          <p:cNvSpPr>
-            <a:spLocks noGrp="1"/>
-          </p:cNvSpPr>
-          <p:nvPr>
-            <p:ph type="title"/>
-          </p:nvPr>
-        </p:nvSpPr>
-        <p:spPr>
-          <a:xfrm>
-            <a:off x="634029" y="1373816"/>
-            <a:ext cx="4704473" cy="2607950"/>
-          </a:xfrm>
-        </p:spPr>
-        <p:txBody>
-          <a:bodyPr/>
-          <a:lstStyle/>
-          <a:p>
-            <a:r>
-              <a:rPr lang="en-US" dirty="0"/>
-              <a:t>Marketing that</a:t>
-            </a:r>
-            <a:br>
-              <a:rPr lang="en-US" dirty="0"/>
-            </a:br>
-            <a:r>
-              <a:rPr lang="en-US" dirty="0"/>
-              <a:t>drives results</a:t>
-            </a:r>
-          </a:p>
-        </p:txBody>
-      </p:sp>
-      <p:sp>
-        <p:nvSpPr>
-          <p:cNvPr id="3" name="Content Placeholder 2">
-            <a:extLst>
-              <a:ext uri="{FF2B5EF4-FFF2-40B4-BE49-F238E27FC236}">
-                <a16:creationId xmlns:a16="http://schemas.microsoft.com/office/drawing/2014/main" id="{3C6EE18F-CF72-C06C-3020-B9FA4DEAB729}"/>
-              </a:ext>
-            </a:extLst>
-          </p:cNvPr>
-          <p:cNvSpPr>
-            <a:spLocks noGrp="1"/>
-          </p:cNvSpPr>
-          <p:nvPr>
-            <p:ph sz="quarter" idx="14"/>
-          </p:nvPr>
-        </p:nvSpPr>
-        <p:spPr>
-          <a:xfrm>
-            <a:off x="634029" y="4362766"/>
-            <a:ext cx="4704473" cy="1860234"/>
-          </a:xfrm>
-        </p:spPr>
-        <p:txBody>
-          <a:bodyPr/>
-          <a:lstStyle/>
-          <a:p>
-            <a:r>
-              <a:rPr lang="en-US" dirty="0"/>
-              <a:t>By staying data-driven and adaptable, our marketing strategy continues to support growth and long-term success.</a:t>
-            </a:r>
-          </a:p>
-        </p:txBody>
-      </p:sp>
-    </p:spTree>
-    <p:extLst>
-      <p:ext uri="{BB962C8B-B14F-4D97-AF65-F5344CB8AC3E}">
-        <p14:creationId xmlns:p14="http://schemas.microsoft.com/office/powerpoint/2010/main" val="2236553916"/>
-      </p:ext>
-    </p:extLst>
-  </p:cSld>
-  <p:clrMapOvr>
-    <a:masterClrMapping/>
-  </p:clrMapOvr>
-</p:sld>
-</file>
-
-<file path=ppt/slides/slide16.xml><?xml version="1.0" encoding="utf-8"?>
-<p:sld xmlns:a="http://schemas.openxmlformats.org/drawingml/2006/main" xmlns:r="http://schemas.openxmlformats.org/officeDocument/2006/relationships" xmlns:p="http://schemas.openxmlformats.org/presentationml/2006/main">
-  <p:cSld>
-    <p:spTree>
-      <p:nvGrpSpPr>
-        <p:cNvPr id="1" name=""/>
-        <p:cNvGrpSpPr/>
-        <p:nvPr/>
-      </p:nvGrpSpPr>
-      <p:grpSpPr>
-        <a:xfrm>
-          <a:off x="0" y="0"/>
-          <a:ext cx="0" cy="0"/>
-          <a:chOff x="0" y="0"/>
-          <a:chExt cx="0" cy="0"/>
-        </a:xfrm>
-      </p:grpSpPr>
-      <p:sp>
-        <p:nvSpPr>
-          <p:cNvPr id="2" name="Title 1">
-            <a:extLst>
-              <a:ext uri="{FF2B5EF4-FFF2-40B4-BE49-F238E27FC236}">
-                <a16:creationId xmlns:a16="http://schemas.microsoft.com/office/drawing/2014/main" id="{29BA87EA-8BB3-79C6-656A-1A8ABD658D7E}"/>
-              </a:ext>
-            </a:extLst>
-          </p:cNvPr>
-          <p:cNvSpPr>
-            <a:spLocks noGrp="1"/>
-          </p:cNvSpPr>
-          <p:nvPr>
-            <p:ph type="ctrTitle"/>
-          </p:nvPr>
-        </p:nvSpPr>
-        <p:spPr>
-          <a:xfrm>
-            <a:off x="634030" y="5109527"/>
-            <a:ext cx="10923934" cy="730884"/>
-          </a:xfrm>
-        </p:spPr>
-        <p:txBody>
-          <a:bodyPr/>
-          <a:lstStyle/>
-          <a:p>
-            <a:r>
-              <a:rPr lang="en-US" dirty="0"/>
-              <a:t>Q &amp; A</a:t>
-            </a:r>
-          </a:p>
-        </p:txBody>
-      </p:sp>
-      <p:sp>
-        <p:nvSpPr>
-          <p:cNvPr id="3" name="Subtitle 2">
-            <a:extLst>
-              <a:ext uri="{FF2B5EF4-FFF2-40B4-BE49-F238E27FC236}">
-                <a16:creationId xmlns:a16="http://schemas.microsoft.com/office/drawing/2014/main" id="{E61DF94A-DA27-1E29-408E-F5360E814FB0}"/>
-              </a:ext>
-            </a:extLst>
-          </p:cNvPr>
-          <p:cNvSpPr>
-            <a:spLocks noGrp="1"/>
-          </p:cNvSpPr>
-          <p:nvPr>
-            <p:ph type="subTitle" idx="1"/>
-          </p:nvPr>
-        </p:nvSpPr>
-        <p:spPr>
-          <a:xfrm>
-            <a:off x="634030" y="5857241"/>
-            <a:ext cx="10923934" cy="382590"/>
-          </a:xfrm>
-        </p:spPr>
-        <p:txBody>
-          <a:bodyPr/>
-          <a:lstStyle/>
-          <a:p>
-            <a:r>
-              <a:rPr lang="en-US" dirty="0"/>
-              <a:t>Let’s discuss questions as a team.</a:t>
-            </a:r>
-          </a:p>
-        </p:txBody>
-      </p:sp>
-      <p:pic>
-        <p:nvPicPr>
-          <p:cNvPr id="9" name="Picture Placeholder 8" descr="A group of people working on computers">
-            <a:extLst>
-              <a:ext uri="{FF2B5EF4-FFF2-40B4-BE49-F238E27FC236}">
-                <a16:creationId xmlns:a16="http://schemas.microsoft.com/office/drawing/2014/main" id="{08B0FE67-3571-D73C-B5B6-9E19F8A9E3FA}"/>
-              </a:ext>
-            </a:extLst>
-          </p:cNvPr>
-          <p:cNvPicPr>
-            <a:picLocks noGrp="1" noChangeAspect="1"/>
-          </p:cNvPicPr>
-          <p:nvPr>
-            <p:ph type="pic" sz="quarter" idx="13"/>
-          </p:nvPr>
-        </p:nvPicPr>
-        <p:blipFill rotWithShape="1">
-          <a:blip r:embed="rId2" cstate="screen">
-            <a:duotone>
-              <a:prstClr val="black"/>
-              <a:srgbClr val="D9C3A5">
-                <a:tint val="50000"/>
-                <a:satMod val="180000"/>
-              </a:srgbClr>
-            </a:duotone>
-            <a:extLst>
-              <a:ext uri="{28A0092B-C50C-407E-A947-70E740481C1C}">
-                <a14:useLocalDpi xmlns:a14="http://schemas.microsoft.com/office/drawing/2010/main"/>
-              </a:ext>
-            </a:extLst>
-          </a:blip>
-          <a:srcRect/>
-          <a:stretch/>
-        </p:blipFill>
-        <p:spPr>
-          <a:xfrm>
-            <a:off x="0" y="1"/>
-            <a:ext cx="12191999" cy="4728526"/>
-          </a:xfrm>
-        </p:spPr>
-      </p:pic>
-    </p:spTree>
-    <p:extLst>
-      <p:ext uri="{BB962C8B-B14F-4D97-AF65-F5344CB8AC3E}">
-        <p14:creationId xmlns:p14="http://schemas.microsoft.com/office/powerpoint/2010/main" val="3272732094"/>
       </p:ext>
     </p:extLst>
   </p:cSld>
@@ -21704,7 +20969,7 @@
         </p:nvSpPr>
         <p:spPr>
           <a:xfrm>
-            <a:off x="275867" y="640080"/>
+            <a:off x="275867" y="545007"/>
             <a:ext cx="5529026" cy="1049681"/>
           </a:xfrm>
         </p:spPr>
@@ -21820,8 +21085,8 @@
         </p:nvSpPr>
         <p:spPr>
           <a:xfrm>
-            <a:off x="275867" y="2167128"/>
-            <a:ext cx="5001768" cy="1631216"/>
+            <a:off x="275867" y="2036311"/>
+            <a:ext cx="5001768" cy="2785378"/>
           </a:xfrm>
           <a:prstGeom prst="rect">
             <a:avLst/>
@@ -21872,6 +21137,31 @@
               <a:t>Behavioral endpoints leave this largely difficult to interpret</a:t>
             </a:r>
           </a:p>
+          <a:p>
+            <a:pPr marL="285750" indent="-285750">
+              <a:buFont typeface="Arial" panose="020B0604020202020204" pitchFamily="34" charset="0"/>
+              <a:buChar char="•"/>
+            </a:pPr>
+            <a:endParaRPr lang="en-US" sz="2500" b="1" dirty="0">
+              <a:solidFill>
+                <a:schemeClr val="accent1"/>
+              </a:solidFill>
+            </a:endParaRPr>
+          </a:p>
+          <a:p>
+            <a:pPr marL="285750" indent="-285750">
+              <a:buFont typeface="Arial" panose="020B0604020202020204" pitchFamily="34" charset="0"/>
+              <a:buChar char="•"/>
+            </a:pPr>
+            <a:r>
+              <a:rPr lang="en-US" sz="2500" b="1" dirty="0">
+                <a:solidFill>
+                  <a:schemeClr val="accent1"/>
+                </a:solidFill>
+              </a:rPr>
+              <a:t>LOTS of heterogeneity &amp; within study var.</a:t>
+            </a:r>
+          </a:p>
         </p:txBody>
       </p:sp>
       <p:sp>
@@ -22201,6 +21491,36 @@
           </a:p>
         </p:txBody>
       </p:sp>
+      <p:pic>
+        <p:nvPicPr>
+          <p:cNvPr id="4" name="Picture 3">
+            <a:extLst>
+              <a:ext uri="{FF2B5EF4-FFF2-40B4-BE49-F238E27FC236}">
+                <a16:creationId xmlns:a16="http://schemas.microsoft.com/office/drawing/2014/main" id="{D4802A65-02B2-E532-28C2-6EF72B32C413}"/>
+              </a:ext>
+            </a:extLst>
+          </p:cNvPr>
+          <p:cNvPicPr>
+            <a:picLocks noChangeAspect="1"/>
+          </p:cNvPicPr>
+          <p:nvPr/>
+        </p:nvPicPr>
+        <p:blipFill>
+          <a:blip r:embed="rId3"/>
+          <a:stretch>
+            <a:fillRect/>
+          </a:stretch>
+        </p:blipFill>
+        <p:spPr>
+          <a:xfrm>
+            <a:off x="2148944" y="4645845"/>
+            <a:ext cx="3383297" cy="2031506"/>
+          </a:xfrm>
+          <a:prstGeom prst="rect">
+            <a:avLst/>
+          </a:prstGeom>
+        </p:spPr>
+      </p:pic>
     </p:spTree>
     <p:extLst>
       <p:ext uri="{BB962C8B-B14F-4D97-AF65-F5344CB8AC3E}">
@@ -22268,54 +21588,165 @@
       </p:sp>
       <p:sp>
         <p:nvSpPr>
-          <p:cNvPr id="6" name="Text Placeholder 5">
-            <a:extLst>
-              <a:ext uri="{FF2B5EF4-FFF2-40B4-BE49-F238E27FC236}">
-                <a16:creationId xmlns:a16="http://schemas.microsoft.com/office/drawing/2014/main" id="{52656EDA-CD5F-E960-B692-34789E2FBE01}"/>
-              </a:ext>
-            </a:extLst>
-          </p:cNvPr>
-          <p:cNvSpPr>
-            <a:spLocks noGrp="1"/>
-          </p:cNvSpPr>
-          <p:nvPr>
-            <p:ph type="body" sz="quarter" idx="14"/>
-          </p:nvPr>
-        </p:nvSpPr>
-        <p:spPr/>
+          <p:cNvPr id="8" name="Text Placeholder 7">
+            <a:extLst>
+              <a:ext uri="{FF2B5EF4-FFF2-40B4-BE49-F238E27FC236}">
+                <a16:creationId xmlns:a16="http://schemas.microsoft.com/office/drawing/2014/main" id="{8D8B12BB-A641-B3D6-FB84-5BB508D99321}"/>
+              </a:ext>
+            </a:extLst>
+          </p:cNvPr>
+          <p:cNvSpPr>
+            <a:spLocks noGrp="1"/>
+          </p:cNvSpPr>
+          <p:nvPr>
+            <p:ph type="body" sz="quarter" idx="13"/>
+          </p:nvPr>
+        </p:nvSpPr>
+        <p:spPr>
+          <a:xfrm>
+            <a:off x="634030" y="1752244"/>
+            <a:ext cx="5266090" cy="4084626"/>
+          </a:xfrm>
+        </p:spPr>
         <p:txBody>
           <a:bodyPr/>
           <a:lstStyle/>
           <a:p>
-            <a:endParaRPr lang="en-US"/>
-          </a:p>
-        </p:txBody>
-      </p:sp>
-      <p:sp>
-        <p:nvSpPr>
-          <p:cNvPr id="8" name="Text Placeholder 7">
-            <a:extLst>
-              <a:ext uri="{FF2B5EF4-FFF2-40B4-BE49-F238E27FC236}">
-                <a16:creationId xmlns:a16="http://schemas.microsoft.com/office/drawing/2014/main" id="{8D8B12BB-A641-B3D6-FB84-5BB508D99321}"/>
-              </a:ext>
-            </a:extLst>
-          </p:cNvPr>
-          <p:cNvSpPr>
-            <a:spLocks noGrp="1"/>
-          </p:cNvSpPr>
-          <p:nvPr>
-            <p:ph type="body" sz="quarter" idx="13"/>
-          </p:nvPr>
-        </p:nvSpPr>
-        <p:spPr/>
-        <p:txBody>
-          <a:bodyPr/>
-          <a:lstStyle/>
-          <a:p>
-            <a:endParaRPr lang="en-US"/>
-          </a:p>
-        </p:txBody>
-      </p:sp>
+            <a:r>
+              <a:rPr lang="en-US" dirty="0"/>
+              <a:t>Moderators </a:t>
+            </a:r>
+            <a:r>
+              <a:rPr lang="en-US" b="1" dirty="0"/>
+              <a:t>reduce</a:t>
+            </a:r>
+            <a:r>
+              <a:rPr lang="en-US" dirty="0"/>
+              <a:t> QE heterogeneity &amp; increase AIC</a:t>
+            </a:r>
+          </a:p>
+          <a:p>
+            <a:r>
+              <a:rPr lang="en-US" dirty="0"/>
+              <a:t>Significantly improved fit (LRT)</a:t>
+            </a:r>
+          </a:p>
+          <a:p>
+            <a:r>
+              <a:rPr lang="en-US" dirty="0"/>
+              <a:t>Only fit some major moderators</a:t>
+            </a:r>
+          </a:p>
+          <a:p>
+            <a:r>
+              <a:rPr lang="en-US" dirty="0"/>
+              <a:t>Within study variance </a:t>
+            </a:r>
+            <a:r>
+              <a:rPr lang="en-US" b="1" dirty="0"/>
+              <a:t>decreases</a:t>
+            </a:r>
+            <a:r>
+              <a:rPr lang="en-US" dirty="0"/>
+              <a:t> but between study variance </a:t>
+            </a:r>
+            <a:r>
+              <a:rPr lang="en-US" b="1" dirty="0"/>
+              <a:t>increases</a:t>
+            </a:r>
+          </a:p>
+        </p:txBody>
+      </p:sp>
+      <p:pic>
+        <p:nvPicPr>
+          <p:cNvPr id="4" name="Picture 3">
+            <a:extLst>
+              <a:ext uri="{FF2B5EF4-FFF2-40B4-BE49-F238E27FC236}">
+                <a16:creationId xmlns:a16="http://schemas.microsoft.com/office/drawing/2014/main" id="{AA9EEF01-1BA9-48AD-F028-63A4D5E9065E}"/>
+              </a:ext>
+            </a:extLst>
+          </p:cNvPr>
+          <p:cNvPicPr>
+            <a:picLocks noChangeAspect="1"/>
+          </p:cNvPicPr>
+          <p:nvPr/>
+        </p:nvPicPr>
+        <p:blipFill>
+          <a:blip r:embed="rId3"/>
+          <a:stretch>
+            <a:fillRect/>
+          </a:stretch>
+        </p:blipFill>
+        <p:spPr>
+          <a:xfrm>
+            <a:off x="99420" y="5836870"/>
+            <a:ext cx="8523326" cy="890688"/>
+          </a:xfrm>
+          <a:prstGeom prst="rect">
+            <a:avLst/>
+          </a:prstGeom>
+        </p:spPr>
+      </p:pic>
+      <p:pic>
+        <p:nvPicPr>
+          <p:cNvPr id="7" name="Picture 6">
+            <a:extLst>
+              <a:ext uri="{FF2B5EF4-FFF2-40B4-BE49-F238E27FC236}">
+                <a16:creationId xmlns:a16="http://schemas.microsoft.com/office/drawing/2014/main" id="{434CFFC2-968D-96EF-20EE-AF54FCB134B0}"/>
+              </a:ext>
+            </a:extLst>
+          </p:cNvPr>
+          <p:cNvPicPr>
+            <a:picLocks noChangeAspect="1"/>
+          </p:cNvPicPr>
+          <p:nvPr/>
+        </p:nvPicPr>
+        <p:blipFill>
+          <a:blip r:embed="rId4"/>
+          <a:stretch>
+            <a:fillRect/>
+          </a:stretch>
+        </p:blipFill>
+        <p:spPr>
+          <a:xfrm>
+            <a:off x="6821424" y="1601926"/>
+            <a:ext cx="4846274" cy="1560665"/>
+          </a:xfrm>
+          <a:prstGeom prst="rect">
+            <a:avLst/>
+          </a:prstGeom>
+        </p:spPr>
+      </p:pic>
+      <p:pic>
+        <p:nvPicPr>
+          <p:cNvPr id="10" name="Picture 9">
+            <a:extLst>
+              <a:ext uri="{FF2B5EF4-FFF2-40B4-BE49-F238E27FC236}">
+                <a16:creationId xmlns:a16="http://schemas.microsoft.com/office/drawing/2014/main" id="{1E22117F-5D24-849E-E80A-EAE7BC6005DC}"/>
+              </a:ext>
+            </a:extLst>
+          </p:cNvPr>
+          <p:cNvPicPr>
+            <a:picLocks noChangeAspect="1"/>
+          </p:cNvPicPr>
+          <p:nvPr/>
+        </p:nvPicPr>
+        <p:blipFill>
+          <a:blip r:embed="rId5"/>
+          <a:stretch>
+            <a:fillRect/>
+          </a:stretch>
+        </p:blipFill>
+        <p:spPr>
+          <a:xfrm>
+            <a:off x="7269526" y="3213182"/>
+            <a:ext cx="4398172" cy="2473370"/>
+          </a:xfrm>
+          <a:prstGeom prst="rect">
+            <a:avLst/>
+          </a:prstGeom>
+        </p:spPr>
+      </p:pic>
     </p:spTree>
     <p:extLst>
       <p:ext uri="{BB962C8B-B14F-4D97-AF65-F5344CB8AC3E}">
@@ -22364,8 +21795,8 @@
         </p:nvSpPr>
         <p:spPr>
           <a:xfrm>
-            <a:off x="634030" y="1748474"/>
-            <a:ext cx="4714880" cy="4622443"/>
+            <a:off x="560878" y="612648"/>
+            <a:ext cx="4714880" cy="1616037"/>
           </a:xfrm>
         </p:spPr>
         <p:txBody>
@@ -22374,7 +21805,200 @@
           <a:p>
             <a:r>
               <a:rPr lang="en-US" dirty="0"/>
-              <a:t>Who is our target audience?</a:t>
+              <a:t>Fish exhibit various behavioral responses to ALAN</a:t>
+            </a:r>
+          </a:p>
+        </p:txBody>
+      </p:sp>
+      <p:sp>
+        <p:nvSpPr>
+          <p:cNvPr id="5" name="Rectangle 4">
+            <a:extLst>
+              <a:ext uri="{FF2B5EF4-FFF2-40B4-BE49-F238E27FC236}">
+                <a16:creationId xmlns:a16="http://schemas.microsoft.com/office/drawing/2014/main" id="{57B881B6-E5F1-0B4A-61D5-D64AE4AB5781}"/>
+              </a:ext>
+            </a:extLst>
+          </p:cNvPr>
+          <p:cNvSpPr/>
+          <p:nvPr/>
+        </p:nvSpPr>
+        <p:spPr>
+          <a:xfrm>
+            <a:off x="6843092" y="1207008"/>
+            <a:ext cx="5348908" cy="4517136"/>
+          </a:xfrm>
+          <a:prstGeom prst="rect">
+            <a:avLst/>
+          </a:prstGeom>
+          <a:ln>
+            <a:noFill/>
+          </a:ln>
+        </p:spPr>
+        <p:style>
+          <a:lnRef idx="2">
+            <a:schemeClr val="accent1">
+              <a:shade val="15000"/>
+            </a:schemeClr>
+          </a:lnRef>
+          <a:fillRef idx="1">
+            <a:schemeClr val="accent1"/>
+          </a:fillRef>
+          <a:effectRef idx="0">
+            <a:schemeClr val="accent1"/>
+          </a:effectRef>
+          <a:fontRef idx="minor">
+            <a:schemeClr val="lt1"/>
+          </a:fontRef>
+        </p:style>
+        <p:txBody>
+          <a:bodyPr rtlCol="0" anchor="ctr"/>
+          <a:lstStyle/>
+          <a:p>
+            <a:pPr algn="ctr"/>
+            <a:endParaRPr lang="en-US"/>
+          </a:p>
+        </p:txBody>
+      </p:sp>
+      <p:pic>
+        <p:nvPicPr>
+          <p:cNvPr id="4" name="Picture 3">
+            <a:extLst>
+              <a:ext uri="{FF2B5EF4-FFF2-40B4-BE49-F238E27FC236}">
+                <a16:creationId xmlns:a16="http://schemas.microsoft.com/office/drawing/2014/main" id="{60C8758B-017B-C172-8955-AEEDBC824EFB}"/>
+              </a:ext>
+            </a:extLst>
+          </p:cNvPr>
+          <p:cNvPicPr>
+            <a:picLocks noChangeAspect="1"/>
+          </p:cNvPicPr>
+          <p:nvPr/>
+        </p:nvPicPr>
+        <p:blipFill>
+          <a:blip r:embed="rId2"/>
+          <a:stretch>
+            <a:fillRect/>
+          </a:stretch>
+        </p:blipFill>
+        <p:spPr>
+          <a:xfrm>
+            <a:off x="5896439" y="1748475"/>
+            <a:ext cx="6295561" cy="3161854"/>
+          </a:xfrm>
+          <a:prstGeom prst="rect">
+            <a:avLst/>
+          </a:prstGeom>
+        </p:spPr>
+      </p:pic>
+      <p:sp>
+        <p:nvSpPr>
+          <p:cNvPr id="6" name="TextBox 5">
+            <a:extLst>
+              <a:ext uri="{FF2B5EF4-FFF2-40B4-BE49-F238E27FC236}">
+                <a16:creationId xmlns:a16="http://schemas.microsoft.com/office/drawing/2014/main" id="{EDEA4E6A-0D05-BEA1-0F61-388E57A57359}"/>
+              </a:ext>
+            </a:extLst>
+          </p:cNvPr>
+          <p:cNvSpPr txBox="1"/>
+          <p:nvPr/>
+        </p:nvSpPr>
+        <p:spPr>
+          <a:xfrm>
+            <a:off x="97873" y="2615184"/>
+            <a:ext cx="5562263" cy="3693319"/>
+          </a:xfrm>
+          <a:prstGeom prst="rect">
+            <a:avLst/>
+          </a:prstGeom>
+          <a:noFill/>
+        </p:spPr>
+        <p:txBody>
+          <a:bodyPr wrap="square" rtlCol="0">
+            <a:spAutoFit/>
+          </a:bodyPr>
+          <a:lstStyle/>
+          <a:p>
+            <a:pPr marL="285750" indent="-285750">
+              <a:buFont typeface="Arial" panose="020B0604020202020204" pitchFamily="34" charset="0"/>
+              <a:buChar char="•"/>
+            </a:pPr>
+            <a:r>
+              <a:rPr lang="en-US" dirty="0"/>
+              <a:t>Fish are less active and more anxious under ALAN</a:t>
+            </a:r>
+          </a:p>
+          <a:p>
+            <a:pPr marL="285750" indent="-285750">
+              <a:buFont typeface="Arial" panose="020B0604020202020204" pitchFamily="34" charset="0"/>
+              <a:buChar char="•"/>
+            </a:pPr>
+            <a:endParaRPr lang="en-US" dirty="0"/>
+          </a:p>
+          <a:p>
+            <a:pPr marL="285750" indent="-285750">
+              <a:buFont typeface="Arial" panose="020B0604020202020204" pitchFamily="34" charset="0"/>
+              <a:buChar char="•"/>
+            </a:pPr>
+            <a:r>
+              <a:rPr lang="en-US" dirty="0"/>
+              <a:t>Activity measured as the mean velocity over several minutes</a:t>
+            </a:r>
+          </a:p>
+          <a:p>
+            <a:pPr marL="285750" indent="-285750">
+              <a:buFont typeface="Arial" panose="020B0604020202020204" pitchFamily="34" charset="0"/>
+              <a:buChar char="•"/>
+            </a:pPr>
+            <a:endParaRPr lang="en-US" dirty="0"/>
+          </a:p>
+          <a:p>
+            <a:pPr marL="285750" indent="-285750">
+              <a:buFont typeface="Arial" panose="020B0604020202020204" pitchFamily="34" charset="0"/>
+              <a:buChar char="•"/>
+            </a:pPr>
+            <a:r>
+              <a:rPr lang="en-US" dirty="0"/>
+              <a:t>Anxiety measured as “thigmotaxis” or wall hugging behavior</a:t>
+            </a:r>
+          </a:p>
+          <a:p>
+            <a:pPr marL="285750" indent="-285750">
+              <a:buFont typeface="Arial" panose="020B0604020202020204" pitchFamily="34" charset="0"/>
+              <a:buChar char="•"/>
+            </a:pPr>
+            <a:endParaRPr lang="en-US" dirty="0"/>
+          </a:p>
+          <a:p>
+            <a:pPr marL="285750" indent="-285750">
+              <a:buFont typeface="Arial" panose="020B0604020202020204" pitchFamily="34" charset="0"/>
+              <a:buChar char="•"/>
+            </a:pPr>
+            <a:r>
+              <a:rPr lang="en-US" dirty="0"/>
+              <a:t>Boldness is often the time to emerge from a shelter</a:t>
+            </a:r>
+          </a:p>
+          <a:p>
+            <a:pPr marL="285750" indent="-285750">
+              <a:buFont typeface="Arial" panose="020B0604020202020204" pitchFamily="34" charset="0"/>
+              <a:buChar char="•"/>
+            </a:pPr>
+            <a:endParaRPr lang="en-US" dirty="0"/>
+          </a:p>
+          <a:p>
+            <a:pPr marL="285750" indent="-285750">
+              <a:buFont typeface="Arial" panose="020B0604020202020204" pitchFamily="34" charset="0"/>
+              <a:buChar char="•"/>
+            </a:pPr>
+            <a:endParaRPr lang="en-US" dirty="0"/>
+          </a:p>
+          <a:p>
+            <a:pPr marL="285750" indent="-285750">
+              <a:buFont typeface="Arial" panose="020B0604020202020204" pitchFamily="34" charset="0"/>
+              <a:buChar char="•"/>
+            </a:pPr>
+            <a:r>
+              <a:rPr lang="en-US" b="1" dirty="0"/>
+              <a:t>Behavioral traits do not perfectly translate across contexts</a:t>
             </a:r>
           </a:p>
         </p:txBody>
@@ -23224,15 +22848,6 @@
 </file>
 
 <file path=customXml/item1.xml><?xml version="1.0" encoding="utf-8"?>
-<?mso-contentType ?>
-<FormTemplates xmlns="http://schemas.microsoft.com/sharepoint/v3/contenttype/forms">
-  <Display>DocumentLibraryForm</Display>
-  <Edit>DocumentLibraryForm</Edit>
-  <New>DocumentLibraryForm</New>
-</FormTemplates>
-</file>
-
-<file path=customXml/item2.xml><?xml version="1.0" encoding="utf-8"?>
 <p:properties xmlns:p="http://schemas.microsoft.com/office/2006/metadata/properties" xmlns:xsi="http://www.w3.org/2001/XMLSchema-instance" xmlns:pc="http://schemas.microsoft.com/office/infopath/2007/PartnerControls">
   <documentManagement>
     <_ip_UnifiedCompliancePolicyUIAction xmlns="http://schemas.microsoft.com/sharepoint/v3" xsi:nil="true"/>
@@ -23250,6 +22865,15 @@
     <MediaServiceKeyPoints xmlns="71af3243-3dd4-4a8d-8c0d-dd76da1f02a5" xsi:nil="true"/>
   </documentManagement>
 </p:properties>
+</file>
+
+<file path=customXml/item2.xml><?xml version="1.0" encoding="utf-8"?>
+<?mso-contentType ?>
+<FormTemplates xmlns="http://schemas.microsoft.com/sharepoint/v3/contenttype/forms">
+  <Display>DocumentLibraryForm</Display>
+  <Edit>DocumentLibraryForm</Edit>
+  <New>DocumentLibraryForm</New>
+</FormTemplates>
 </file>
 
 <file path=customXml/item3.xml><?xml version="1.0" encoding="utf-8"?>
@@ -23571,14 +23195,6 @@
 </file>
 
 <file path=customXml/itemProps1.xml><?xml version="1.0" encoding="utf-8"?>
-<ds:datastoreItem xmlns:ds="http://schemas.openxmlformats.org/officeDocument/2006/customXml" ds:itemID="{D3301439-688F-4D19-B908-B48B62C56078}">
-  <ds:schemaRefs>
-    <ds:schemaRef ds:uri="http://schemas.microsoft.com/sharepoint/v3/contenttype/forms"/>
-  </ds:schemaRefs>
-</ds:datastoreItem>
-</file>
-
-<file path=customXml/itemProps2.xml><?xml version="1.0" encoding="utf-8"?>
 <ds:datastoreItem xmlns:ds="http://schemas.openxmlformats.org/officeDocument/2006/customXml" ds:itemID="{D1CEDABF-7176-4A42-8EF9-E5D4DD31FF6C}">
   <ds:schemaRefs>
     <ds:schemaRef ds:uri="71af3243-3dd4-4a8d-8c0d-dd76da1f02a5"/>
@@ -23593,6 +23209,14 @@
     <ds:schemaRef ds:uri="http://schemas.microsoft.com/office/infopath/2007/PartnerControls"/>
     <ds:schemaRef ds:uri="http://schemas.openxmlformats.org/package/2006/metadata/core-properties"/>
     <ds:schemaRef ds:uri="230e9df3-be65-4c73-a93b-d1236ebd677e"/>
+  </ds:schemaRefs>
+</ds:datastoreItem>
+</file>
+
+<file path=customXml/itemProps2.xml><?xml version="1.0" encoding="utf-8"?>
+<ds:datastoreItem xmlns:ds="http://schemas.openxmlformats.org/officeDocument/2006/customXml" ds:itemID="{D3301439-688F-4D19-B908-B48B62C56078}">
+  <ds:schemaRefs>
+    <ds:schemaRef ds:uri="http://schemas.microsoft.com/sharepoint/v3/contenttype/forms"/>
   </ds:schemaRefs>
 </ds:datastoreItem>
 </file>

</xml_diff>